<commit_message>
slide 04: hablar de TimescaleDB (extension, necesidad y aporte); README sin referencias personales; quitar kickers de todas las slides
</commit_message>
<xml_diff>
--- a/presentacion/TimescaleDB-PPT-Javier.pptx
+++ b/presentacion/TimescaleDB-PPT-Javier.pptx
@@ -3549,8 +3549,8 @@
         </p:nvSpPr>
         <p:spPr>
           <a:xfrm>
-            <a:off x="548640" y="411479"/>
-            <a:ext cx="8229600" cy="320040"/>
+            <a:off x="548640" y="457200"/>
+            <a:ext cx="11064240" cy="548640"/>
           </a:xfrm>
           <a:prstGeom prst="rect">
             <a:avLst/>
@@ -3570,54 +3570,6 @@
               <a:spcAft>
                 <a:spcPts val="0"/>
               </a:spcAft>
-              <a:defRPr sz="1300" b="1">
-                <a:solidFill>
-                  <a:srgbClr val="FBBF24"/>
-                </a:solidFill>
-                <a:latin typeface="Helvetica Neue"/>
-              </a:defRPr>
-            </a:pPr>
-            <a:r>
-              <a:rPr>
-                <a:solidFill>
-                  <a:srgbClr val="FBBF24"/>
-                </a:solidFill>
-                <a:latin typeface="Helvetica Neue"/>
-              </a:rPr>
-              <a:t>APARTADO 05 · AUTOMATIZACIÓN</a:t>
-            </a:r>
-          </a:p>
-        </p:txBody>
-      </p:sp>
-      <p:sp>
-        <p:nvSpPr>
-          <p:cNvPr id="4" name="TextBox 3"/>
-          <p:cNvSpPr txBox="1"/>
-          <p:nvPr/>
-        </p:nvSpPr>
-        <p:spPr>
-          <a:xfrm>
-            <a:off x="548640" y="676656"/>
-            <a:ext cx="11064240" cy="548640"/>
-          </a:xfrm>
-          <a:prstGeom prst="rect">
-            <a:avLst/>
-          </a:prstGeom>
-          <a:noFill/>
-        </p:spPr>
-        <p:txBody>
-          <a:bodyPr wrap="square" anchor="t" lIns="0" rIns="0" tIns="0" bIns="0">
-            <a:spAutoFit/>
-          </a:bodyPr>
-          <a:lstStyle/>
-          <a:p>
-            <a:pPr algn="l">
-              <a:spcBef>
-                <a:spcPts val="0"/>
-              </a:spcBef>
-              <a:spcAft>
-                <a:spcPts val="0"/>
-              </a:spcAft>
               <a:defRPr sz="3000" b="1">
                 <a:solidFill>
                   <a:srgbClr val="E2E8F0"/>
@@ -3639,13 +3591,13 @@
       </p:sp>
       <p:sp>
         <p:nvSpPr>
-          <p:cNvPr id="5" name="Rectangle 4"/>
+          <p:cNvPr id="4" name="Rectangle 3"/>
           <p:cNvSpPr/>
           <p:nvPr/>
         </p:nvSpPr>
         <p:spPr>
           <a:xfrm>
-            <a:off x="548640" y="1033271"/>
+            <a:off x="548640" y="813816"/>
             <a:ext cx="960120" cy="41148"/>
           </a:xfrm>
           <a:prstGeom prst="rect">
@@ -3683,7 +3635,7 @@
       </p:sp>
       <p:sp>
         <p:nvSpPr>
-          <p:cNvPr id="6" name="Rectangle 5"/>
+          <p:cNvPr id="5" name="Rectangle 4"/>
           <p:cNvSpPr/>
           <p:nvPr/>
         </p:nvSpPr>
@@ -3727,7 +3679,7 @@
       </p:sp>
       <p:sp>
         <p:nvSpPr>
-          <p:cNvPr id="7" name="TextBox 6"/>
+          <p:cNvPr id="6" name="TextBox 5"/>
           <p:cNvSpPr txBox="1"/>
           <p:nvPr/>
         </p:nvSpPr>
@@ -3775,7 +3727,7 @@
       </p:sp>
       <p:sp>
         <p:nvSpPr>
-          <p:cNvPr id="8" name="TextBox 7"/>
+          <p:cNvPr id="7" name="TextBox 6"/>
           <p:cNvSpPr txBox="1"/>
           <p:nvPr/>
         </p:nvSpPr>
@@ -3823,7 +3775,7 @@
       </p:sp>
       <p:sp>
         <p:nvSpPr>
-          <p:cNvPr id="9" name="Rounded Rectangle 8"/>
+          <p:cNvPr id="8" name="Rounded Rectangle 7"/>
           <p:cNvSpPr/>
           <p:nvPr/>
         </p:nvSpPr>
@@ -3869,7 +3821,7 @@
       </p:sp>
       <p:sp>
         <p:nvSpPr>
-          <p:cNvPr id="10" name="TextBox 9"/>
+          <p:cNvPr id="9" name="TextBox 8"/>
           <p:cNvSpPr txBox="1"/>
           <p:nvPr/>
         </p:nvSpPr>
@@ -4058,7 +4010,7 @@
       </p:sp>
       <p:sp>
         <p:nvSpPr>
-          <p:cNvPr id="11" name="TextBox 10"/>
+          <p:cNvPr id="10" name="TextBox 9"/>
           <p:cNvSpPr txBox="1"/>
           <p:nvPr/>
         </p:nvSpPr>
@@ -4289,7 +4241,7 @@
       </p:sp>
       <p:sp>
         <p:nvSpPr>
-          <p:cNvPr id="12" name="Rounded Rectangle 11"/>
+          <p:cNvPr id="11" name="Rounded Rectangle 10"/>
           <p:cNvSpPr/>
           <p:nvPr/>
         </p:nvSpPr>
@@ -4335,7 +4287,7 @@
       </p:sp>
       <p:sp>
         <p:nvSpPr>
-          <p:cNvPr id="13" name="TextBox 12"/>
+          <p:cNvPr id="12" name="TextBox 11"/>
           <p:cNvSpPr txBox="1"/>
           <p:nvPr/>
         </p:nvSpPr>
@@ -4526,8 +4478,8 @@
         </p:nvSpPr>
         <p:spPr>
           <a:xfrm>
-            <a:off x="548640" y="411479"/>
-            <a:ext cx="8229600" cy="320040"/>
+            <a:off x="548640" y="457200"/>
+            <a:ext cx="11064240" cy="548640"/>
           </a:xfrm>
           <a:prstGeom prst="rect">
             <a:avLst/>
@@ -4547,54 +4499,6 @@
               <a:spcAft>
                 <a:spcPts val="0"/>
               </a:spcAft>
-              <a:defRPr sz="1300" b="1">
-                <a:solidFill>
-                  <a:srgbClr val="FBBF24"/>
-                </a:solidFill>
-                <a:latin typeface="Helvetica Neue"/>
-              </a:defRPr>
-            </a:pPr>
-            <a:r>
-              <a:rPr>
-                <a:solidFill>
-                  <a:srgbClr val="FBBF24"/>
-                </a:solidFill>
-                <a:latin typeface="Helvetica Neue"/>
-              </a:rPr>
-              <a:t>APARTADO 06 · LEER RÁPIDO</a:t>
-            </a:r>
-          </a:p>
-        </p:txBody>
-      </p:sp>
-      <p:sp>
-        <p:nvSpPr>
-          <p:cNvPr id="4" name="TextBox 3"/>
-          <p:cNvSpPr txBox="1"/>
-          <p:nvPr/>
-        </p:nvSpPr>
-        <p:spPr>
-          <a:xfrm>
-            <a:off x="548640" y="676656"/>
-            <a:ext cx="11064240" cy="548640"/>
-          </a:xfrm>
-          <a:prstGeom prst="rect">
-            <a:avLst/>
-          </a:prstGeom>
-          <a:noFill/>
-        </p:spPr>
-        <p:txBody>
-          <a:bodyPr wrap="square" anchor="t" lIns="0" rIns="0" tIns="0" bIns="0">
-            <a:spAutoFit/>
-          </a:bodyPr>
-          <a:lstStyle/>
-          <a:p>
-            <a:pPr algn="l">
-              <a:spcBef>
-                <a:spcPts val="0"/>
-              </a:spcBef>
-              <a:spcAft>
-                <a:spcPts val="0"/>
-              </a:spcAft>
               <a:defRPr sz="3000" b="1">
                 <a:solidFill>
                   <a:srgbClr val="E2E8F0"/>
@@ -4616,13 +4520,13 @@
       </p:sp>
       <p:sp>
         <p:nvSpPr>
-          <p:cNvPr id="5" name="Rectangle 4"/>
+          <p:cNvPr id="4" name="Rectangle 3"/>
           <p:cNvSpPr/>
           <p:nvPr/>
         </p:nvSpPr>
         <p:spPr>
           <a:xfrm>
-            <a:off x="548640" y="1033271"/>
+            <a:off x="548640" y="813816"/>
             <a:ext cx="960120" cy="41148"/>
           </a:xfrm>
           <a:prstGeom prst="rect">
@@ -4660,7 +4564,7 @@
       </p:sp>
       <p:sp>
         <p:nvSpPr>
-          <p:cNvPr id="6" name="Rectangle 5"/>
+          <p:cNvPr id="5" name="Rectangle 4"/>
           <p:cNvSpPr/>
           <p:nvPr/>
         </p:nvSpPr>
@@ -4704,7 +4608,7 @@
       </p:sp>
       <p:sp>
         <p:nvSpPr>
-          <p:cNvPr id="7" name="TextBox 6"/>
+          <p:cNvPr id="6" name="TextBox 5"/>
           <p:cNvSpPr txBox="1"/>
           <p:nvPr/>
         </p:nvSpPr>
@@ -4752,7 +4656,7 @@
       </p:sp>
       <p:sp>
         <p:nvSpPr>
-          <p:cNvPr id="8" name="TextBox 7"/>
+          <p:cNvPr id="7" name="TextBox 6"/>
           <p:cNvSpPr txBox="1"/>
           <p:nvPr/>
         </p:nvSpPr>
@@ -4800,7 +4704,7 @@
       </p:sp>
       <p:sp>
         <p:nvSpPr>
-          <p:cNvPr id="9" name="Rectangle 8"/>
+          <p:cNvPr id="8" name="Rectangle 7"/>
           <p:cNvSpPr/>
           <p:nvPr/>
         </p:nvSpPr>
@@ -4844,7 +4748,7 @@
       </p:sp>
       <p:sp>
         <p:nvSpPr>
-          <p:cNvPr id="10" name="TextBox 9"/>
+          <p:cNvPr id="9" name="TextBox 8"/>
           <p:cNvSpPr txBox="1"/>
           <p:nvPr/>
         </p:nvSpPr>
@@ -4892,7 +4796,7 @@
       </p:sp>
       <p:sp>
         <p:nvSpPr>
-          <p:cNvPr id="11" name="TextBox 10"/>
+          <p:cNvPr id="10" name="TextBox 9"/>
           <p:cNvSpPr txBox="1"/>
           <p:nvPr/>
         </p:nvSpPr>
@@ -4940,7 +4844,7 @@
       </p:sp>
       <p:sp>
         <p:nvSpPr>
-          <p:cNvPr id="12" name="TextBox 11"/>
+          <p:cNvPr id="11" name="TextBox 10"/>
           <p:cNvSpPr txBox="1"/>
           <p:nvPr/>
         </p:nvSpPr>
@@ -4988,7 +4892,7 @@
       </p:sp>
       <p:sp>
         <p:nvSpPr>
-          <p:cNvPr id="13" name="Rectangle 12"/>
+          <p:cNvPr id="12" name="Rectangle 11"/>
           <p:cNvSpPr/>
           <p:nvPr/>
         </p:nvSpPr>
@@ -5032,7 +4936,7 @@
       </p:sp>
       <p:sp>
         <p:nvSpPr>
-          <p:cNvPr id="14" name="TextBox 13"/>
+          <p:cNvPr id="13" name="TextBox 12"/>
           <p:cNvSpPr txBox="1"/>
           <p:nvPr/>
         </p:nvSpPr>
@@ -5080,7 +4984,7 @@
       </p:sp>
       <p:sp>
         <p:nvSpPr>
-          <p:cNvPr id="15" name="TextBox 14"/>
+          <p:cNvPr id="14" name="TextBox 13"/>
           <p:cNvSpPr txBox="1"/>
           <p:nvPr/>
         </p:nvSpPr>
@@ -5128,7 +5032,7 @@
       </p:sp>
       <p:sp>
         <p:nvSpPr>
-          <p:cNvPr id="16" name="TextBox 15"/>
+          <p:cNvPr id="15" name="TextBox 14"/>
           <p:cNvSpPr txBox="1"/>
           <p:nvPr/>
         </p:nvSpPr>
@@ -5176,7 +5080,7 @@
       </p:sp>
       <p:sp>
         <p:nvSpPr>
-          <p:cNvPr id="17" name="Rectangle 16"/>
+          <p:cNvPr id="16" name="Rectangle 15"/>
           <p:cNvSpPr/>
           <p:nvPr/>
         </p:nvSpPr>
@@ -5220,7 +5124,7 @@
       </p:sp>
       <p:sp>
         <p:nvSpPr>
-          <p:cNvPr id="18" name="TextBox 17"/>
+          <p:cNvPr id="17" name="TextBox 16"/>
           <p:cNvSpPr txBox="1"/>
           <p:nvPr/>
         </p:nvSpPr>
@@ -5268,7 +5172,7 @@
       </p:sp>
       <p:sp>
         <p:nvSpPr>
-          <p:cNvPr id="19" name="TextBox 18"/>
+          <p:cNvPr id="18" name="TextBox 17"/>
           <p:cNvSpPr txBox="1"/>
           <p:nvPr/>
         </p:nvSpPr>
@@ -5316,7 +5220,7 @@
       </p:sp>
       <p:sp>
         <p:nvSpPr>
-          <p:cNvPr id="20" name="TextBox 19"/>
+          <p:cNvPr id="19" name="TextBox 18"/>
           <p:cNvSpPr txBox="1"/>
           <p:nvPr/>
         </p:nvSpPr>
@@ -5364,7 +5268,7 @@
       </p:sp>
       <p:sp>
         <p:nvSpPr>
-          <p:cNvPr id="21" name="Rectangle 20"/>
+          <p:cNvPr id="20" name="Rectangle 19"/>
           <p:cNvSpPr/>
           <p:nvPr/>
         </p:nvSpPr>
@@ -5408,7 +5312,7 @@
       </p:sp>
       <p:sp>
         <p:nvSpPr>
-          <p:cNvPr id="22" name="TextBox 21"/>
+          <p:cNvPr id="21" name="TextBox 20"/>
           <p:cNvSpPr txBox="1"/>
           <p:nvPr/>
         </p:nvSpPr>
@@ -5456,7 +5360,7 @@
       </p:sp>
       <p:sp>
         <p:nvSpPr>
-          <p:cNvPr id="23" name="TextBox 22"/>
+          <p:cNvPr id="22" name="TextBox 21"/>
           <p:cNvSpPr txBox="1"/>
           <p:nvPr/>
         </p:nvSpPr>
@@ -5504,7 +5408,7 @@
       </p:sp>
       <p:sp>
         <p:nvSpPr>
-          <p:cNvPr id="24" name="TextBox 23"/>
+          <p:cNvPr id="23" name="TextBox 22"/>
           <p:cNvSpPr txBox="1"/>
           <p:nvPr/>
         </p:nvSpPr>
@@ -5552,7 +5456,7 @@
       </p:sp>
       <p:sp>
         <p:nvSpPr>
-          <p:cNvPr id="25" name="Rectangle 24"/>
+          <p:cNvPr id="24" name="Rectangle 23"/>
           <p:cNvSpPr/>
           <p:nvPr/>
         </p:nvSpPr>
@@ -5596,7 +5500,7 @@
       </p:sp>
       <p:sp>
         <p:nvSpPr>
-          <p:cNvPr id="26" name="TextBox 25"/>
+          <p:cNvPr id="25" name="TextBox 24"/>
           <p:cNvSpPr txBox="1"/>
           <p:nvPr/>
         </p:nvSpPr>
@@ -5644,7 +5548,7 @@
       </p:sp>
       <p:sp>
         <p:nvSpPr>
-          <p:cNvPr id="27" name="TextBox 26"/>
+          <p:cNvPr id="26" name="TextBox 25"/>
           <p:cNvSpPr txBox="1"/>
           <p:nvPr/>
         </p:nvSpPr>
@@ -5692,7 +5596,7 @@
       </p:sp>
       <p:sp>
         <p:nvSpPr>
-          <p:cNvPr id="28" name="TextBox 27"/>
+          <p:cNvPr id="27" name="TextBox 26"/>
           <p:cNvSpPr txBox="1"/>
           <p:nvPr/>
         </p:nvSpPr>
@@ -5740,7 +5644,7 @@
       </p:sp>
       <p:sp>
         <p:nvSpPr>
-          <p:cNvPr id="29" name="TextBox 28"/>
+          <p:cNvPr id="28" name="TextBox 27"/>
           <p:cNvSpPr txBox="1"/>
           <p:nvPr/>
         </p:nvSpPr>
@@ -5797,7 +5701,7 @@
       </p:sp>
       <p:sp>
         <p:nvSpPr>
-          <p:cNvPr id="30" name="TextBox 29"/>
+          <p:cNvPr id="29" name="TextBox 28"/>
           <p:cNvSpPr txBox="1"/>
           <p:nvPr/>
         </p:nvSpPr>
@@ -5845,7 +5749,7 @@
       </p:sp>
       <p:sp>
         <p:nvSpPr>
-          <p:cNvPr id="31" name="TextBox 30"/>
+          <p:cNvPr id="30" name="TextBox 29"/>
           <p:cNvSpPr txBox="1"/>
           <p:nvPr/>
         </p:nvSpPr>
@@ -5961,8 +5865,8 @@
         </p:nvSpPr>
         <p:spPr>
           <a:xfrm>
-            <a:off x="548640" y="411479"/>
-            <a:ext cx="8229600" cy="320040"/>
+            <a:off x="548640" y="457200"/>
+            <a:ext cx="11064240" cy="548640"/>
           </a:xfrm>
           <a:prstGeom prst="rect">
             <a:avLst/>
@@ -5982,54 +5886,6 @@
               <a:spcAft>
                 <a:spcPts val="0"/>
               </a:spcAft>
-              <a:defRPr sz="1300" b="1">
-                <a:solidFill>
-                  <a:srgbClr val="FBBF24"/>
-                </a:solidFill>
-                <a:latin typeface="Helvetica Neue"/>
-              </a:defRPr>
-            </a:pPr>
-            <a:r>
-              <a:rPr>
-                <a:solidFill>
-                  <a:srgbClr val="FBBF24"/>
-                </a:solidFill>
-                <a:latin typeface="Helvetica Neue"/>
-              </a:rPr>
-              <a:t>APARTADO 07 · CICLO DE VIDA</a:t>
-            </a:r>
-          </a:p>
-        </p:txBody>
-      </p:sp>
-      <p:sp>
-        <p:nvSpPr>
-          <p:cNvPr id="4" name="TextBox 3"/>
-          <p:cNvSpPr txBox="1"/>
-          <p:nvPr/>
-        </p:nvSpPr>
-        <p:spPr>
-          <a:xfrm>
-            <a:off x="548640" y="676656"/>
-            <a:ext cx="11064240" cy="548640"/>
-          </a:xfrm>
-          <a:prstGeom prst="rect">
-            <a:avLst/>
-          </a:prstGeom>
-          <a:noFill/>
-        </p:spPr>
-        <p:txBody>
-          <a:bodyPr wrap="square" anchor="t" lIns="0" rIns="0" tIns="0" bIns="0">
-            <a:spAutoFit/>
-          </a:bodyPr>
-          <a:lstStyle/>
-          <a:p>
-            <a:pPr algn="l">
-              <a:spcBef>
-                <a:spcPts val="0"/>
-              </a:spcBef>
-              <a:spcAft>
-                <a:spcPts val="0"/>
-              </a:spcAft>
               <a:defRPr sz="3000" b="1">
                 <a:solidFill>
                   <a:srgbClr val="E2E8F0"/>
@@ -6051,13 +5907,13 @@
       </p:sp>
       <p:sp>
         <p:nvSpPr>
-          <p:cNvPr id="5" name="Rectangle 4"/>
+          <p:cNvPr id="4" name="Rectangle 3"/>
           <p:cNvSpPr/>
           <p:nvPr/>
         </p:nvSpPr>
         <p:spPr>
           <a:xfrm>
-            <a:off x="548640" y="1033271"/>
+            <a:off x="548640" y="813816"/>
             <a:ext cx="960120" cy="41148"/>
           </a:xfrm>
           <a:prstGeom prst="rect">
@@ -6095,7 +5951,7 @@
       </p:sp>
       <p:sp>
         <p:nvSpPr>
-          <p:cNvPr id="6" name="Rectangle 5"/>
+          <p:cNvPr id="5" name="Rectangle 4"/>
           <p:cNvSpPr/>
           <p:nvPr/>
         </p:nvSpPr>
@@ -6139,7 +5995,7 @@
       </p:sp>
       <p:sp>
         <p:nvSpPr>
-          <p:cNvPr id="7" name="TextBox 6"/>
+          <p:cNvPr id="6" name="TextBox 5"/>
           <p:cNvSpPr txBox="1"/>
           <p:nvPr/>
         </p:nvSpPr>
@@ -6187,7 +6043,7 @@
       </p:sp>
       <p:sp>
         <p:nvSpPr>
-          <p:cNvPr id="8" name="TextBox 7"/>
+          <p:cNvPr id="7" name="TextBox 6"/>
           <p:cNvSpPr txBox="1"/>
           <p:nvPr/>
         </p:nvSpPr>
@@ -6235,7 +6091,7 @@
       </p:sp>
       <p:sp>
         <p:nvSpPr>
-          <p:cNvPr id="9" name="Rounded Rectangle 8"/>
+          <p:cNvPr id="8" name="Rounded Rectangle 7"/>
           <p:cNvSpPr/>
           <p:nvPr/>
         </p:nvSpPr>
@@ -6281,7 +6137,7 @@
       </p:sp>
       <p:sp>
         <p:nvSpPr>
-          <p:cNvPr id="10" name="TextBox 9"/>
+          <p:cNvPr id="9" name="TextBox 8"/>
           <p:cNvSpPr txBox="1"/>
           <p:nvPr/>
         </p:nvSpPr>
@@ -6445,7 +6301,7 @@
       </p:sp>
       <p:sp>
         <p:nvSpPr>
-          <p:cNvPr id="11" name="TextBox 10"/>
+          <p:cNvPr id="10" name="TextBox 9"/>
           <p:cNvSpPr txBox="1"/>
           <p:nvPr/>
         </p:nvSpPr>
@@ -6669,7 +6525,7 @@
       </p:sp>
       <p:sp>
         <p:nvSpPr>
-          <p:cNvPr id="12" name="Rounded Rectangle 11"/>
+          <p:cNvPr id="11" name="Rounded Rectangle 10"/>
           <p:cNvSpPr/>
           <p:nvPr/>
         </p:nvSpPr>
@@ -6715,7 +6571,7 @@
       </p:sp>
       <p:sp>
         <p:nvSpPr>
-          <p:cNvPr id="13" name="TextBox 12"/>
+          <p:cNvPr id="12" name="TextBox 11"/>
           <p:cNvSpPr txBox="1"/>
           <p:nvPr/>
         </p:nvSpPr>
@@ -6856,8 +6712,8 @@
         </p:nvSpPr>
         <p:spPr>
           <a:xfrm>
-            <a:off x="548640" y="411479"/>
-            <a:ext cx="8229600" cy="320040"/>
+            <a:off x="548640" y="457200"/>
+            <a:ext cx="11064240" cy="548640"/>
           </a:xfrm>
           <a:prstGeom prst="rect">
             <a:avLst/>
@@ -6877,54 +6733,6 @@
               <a:spcAft>
                 <a:spcPts val="0"/>
               </a:spcAft>
-              <a:defRPr sz="1300" b="1">
-                <a:solidFill>
-                  <a:srgbClr val="FBBF24"/>
-                </a:solidFill>
-                <a:latin typeface="Helvetica Neue"/>
-              </a:defRPr>
-            </a:pPr>
-            <a:r>
-              <a:rPr>
-                <a:solidFill>
-                  <a:srgbClr val="FBBF24"/>
-                </a:solidFill>
-                <a:latin typeface="Helvetica Neue"/>
-              </a:rPr>
-              <a:t>APARTADO 08 · DOWNSAMPLING</a:t>
-            </a:r>
-          </a:p>
-        </p:txBody>
-      </p:sp>
-      <p:sp>
-        <p:nvSpPr>
-          <p:cNvPr id="4" name="TextBox 3"/>
-          <p:cNvSpPr txBox="1"/>
-          <p:nvPr/>
-        </p:nvSpPr>
-        <p:spPr>
-          <a:xfrm>
-            <a:off x="548640" y="676656"/>
-            <a:ext cx="11064240" cy="548640"/>
-          </a:xfrm>
-          <a:prstGeom prst="rect">
-            <a:avLst/>
-          </a:prstGeom>
-          <a:noFill/>
-        </p:spPr>
-        <p:txBody>
-          <a:bodyPr wrap="square" anchor="t" lIns="0" rIns="0" tIns="0" bIns="0">
-            <a:spAutoFit/>
-          </a:bodyPr>
-          <a:lstStyle/>
-          <a:p>
-            <a:pPr algn="l">
-              <a:spcBef>
-                <a:spcPts val="0"/>
-              </a:spcBef>
-              <a:spcAft>
-                <a:spcPts val="0"/>
-              </a:spcAft>
               <a:defRPr sz="3000" b="1">
                 <a:solidFill>
                   <a:srgbClr val="E2E8F0"/>
@@ -6946,13 +6754,13 @@
       </p:sp>
       <p:sp>
         <p:nvSpPr>
-          <p:cNvPr id="5" name="Rectangle 4"/>
+          <p:cNvPr id="4" name="Rectangle 3"/>
           <p:cNvSpPr/>
           <p:nvPr/>
         </p:nvSpPr>
         <p:spPr>
           <a:xfrm>
-            <a:off x="548640" y="1033271"/>
+            <a:off x="548640" y="813816"/>
             <a:ext cx="960120" cy="41148"/>
           </a:xfrm>
           <a:prstGeom prst="rect">
@@ -6990,7 +6798,7 @@
       </p:sp>
       <p:sp>
         <p:nvSpPr>
-          <p:cNvPr id="6" name="Rectangle 5"/>
+          <p:cNvPr id="5" name="Rectangle 4"/>
           <p:cNvSpPr/>
           <p:nvPr/>
         </p:nvSpPr>
@@ -7034,7 +6842,7 @@
       </p:sp>
       <p:sp>
         <p:nvSpPr>
-          <p:cNvPr id="7" name="TextBox 6"/>
+          <p:cNvPr id="6" name="TextBox 5"/>
           <p:cNvSpPr txBox="1"/>
           <p:nvPr/>
         </p:nvSpPr>
@@ -7082,7 +6890,7 @@
       </p:sp>
       <p:sp>
         <p:nvSpPr>
-          <p:cNvPr id="8" name="TextBox 7"/>
+          <p:cNvPr id="7" name="TextBox 6"/>
           <p:cNvSpPr txBox="1"/>
           <p:nvPr/>
         </p:nvSpPr>
@@ -7130,7 +6938,7 @@
       </p:sp>
       <p:sp>
         <p:nvSpPr>
-          <p:cNvPr id="9" name="Rounded Rectangle 8"/>
+          <p:cNvPr id="8" name="Rounded Rectangle 7"/>
           <p:cNvSpPr/>
           <p:nvPr/>
         </p:nvSpPr>
@@ -7176,7 +6984,7 @@
       </p:sp>
       <p:sp>
         <p:nvSpPr>
-          <p:cNvPr id="10" name="TextBox 9"/>
+          <p:cNvPr id="9" name="TextBox 8"/>
           <p:cNvSpPr txBox="1"/>
           <p:nvPr/>
         </p:nvSpPr>
@@ -7324,7 +7132,7 @@
       </p:sp>
       <p:sp>
         <p:nvSpPr>
-          <p:cNvPr id="11" name="TextBox 10"/>
+          <p:cNvPr id="10" name="TextBox 9"/>
           <p:cNvSpPr txBox="1"/>
           <p:nvPr/>
         </p:nvSpPr>
@@ -7530,7 +7338,7 @@
       </p:sp>
       <p:sp>
         <p:nvSpPr>
-          <p:cNvPr id="12" name="Rectangle 11"/>
+          <p:cNvPr id="11" name="Rectangle 10"/>
           <p:cNvSpPr/>
           <p:nvPr/>
         </p:nvSpPr>
@@ -7574,7 +7382,7 @@
       </p:sp>
       <p:sp>
         <p:nvSpPr>
-          <p:cNvPr id="13" name="TextBox 12"/>
+          <p:cNvPr id="12" name="TextBox 11"/>
           <p:cNvSpPr txBox="1"/>
           <p:nvPr/>
         </p:nvSpPr>
@@ -7622,7 +7430,7 @@
       </p:sp>
       <p:sp>
         <p:nvSpPr>
-          <p:cNvPr id="14" name="TextBox 13"/>
+          <p:cNvPr id="13" name="TextBox 12"/>
           <p:cNvSpPr txBox="1"/>
           <p:nvPr/>
         </p:nvSpPr>
@@ -7670,7 +7478,7 @@
       </p:sp>
       <p:sp>
         <p:nvSpPr>
-          <p:cNvPr id="15" name="TextBox 14"/>
+          <p:cNvPr id="14" name="TextBox 13"/>
           <p:cNvSpPr txBox="1"/>
           <p:nvPr/>
         </p:nvSpPr>
@@ -7718,7 +7526,7 @@
       </p:sp>
       <p:sp>
         <p:nvSpPr>
-          <p:cNvPr id="16" name="Rectangle 15"/>
+          <p:cNvPr id="15" name="Rectangle 14"/>
           <p:cNvSpPr/>
           <p:nvPr/>
         </p:nvSpPr>
@@ -7762,7 +7570,7 @@
       </p:sp>
       <p:sp>
         <p:nvSpPr>
-          <p:cNvPr id="17" name="TextBox 16"/>
+          <p:cNvPr id="16" name="TextBox 15"/>
           <p:cNvSpPr txBox="1"/>
           <p:nvPr/>
         </p:nvSpPr>
@@ -7810,7 +7618,7 @@
       </p:sp>
       <p:sp>
         <p:nvSpPr>
-          <p:cNvPr id="18" name="TextBox 17"/>
+          <p:cNvPr id="17" name="TextBox 16"/>
           <p:cNvSpPr txBox="1"/>
           <p:nvPr/>
         </p:nvSpPr>
@@ -7858,7 +7666,7 @@
       </p:sp>
       <p:sp>
         <p:nvSpPr>
-          <p:cNvPr id="19" name="TextBox 18"/>
+          <p:cNvPr id="18" name="TextBox 17"/>
           <p:cNvSpPr txBox="1"/>
           <p:nvPr/>
         </p:nvSpPr>
@@ -7906,7 +7714,7 @@
       </p:sp>
       <p:sp>
         <p:nvSpPr>
-          <p:cNvPr id="20" name="Rectangle 19"/>
+          <p:cNvPr id="19" name="Rectangle 18"/>
           <p:cNvSpPr/>
           <p:nvPr/>
         </p:nvSpPr>
@@ -7950,7 +7758,7 @@
       </p:sp>
       <p:sp>
         <p:nvSpPr>
-          <p:cNvPr id="21" name="TextBox 20"/>
+          <p:cNvPr id="20" name="TextBox 19"/>
           <p:cNvSpPr txBox="1"/>
           <p:nvPr/>
         </p:nvSpPr>
@@ -7998,7 +7806,7 @@
       </p:sp>
       <p:sp>
         <p:nvSpPr>
-          <p:cNvPr id="22" name="TextBox 21"/>
+          <p:cNvPr id="21" name="TextBox 20"/>
           <p:cNvSpPr txBox="1"/>
           <p:nvPr/>
         </p:nvSpPr>
@@ -8046,7 +7854,7 @@
       </p:sp>
       <p:sp>
         <p:nvSpPr>
-          <p:cNvPr id="23" name="TextBox 22"/>
+          <p:cNvPr id="22" name="TextBox 21"/>
           <p:cNvSpPr txBox="1"/>
           <p:nvPr/>
         </p:nvSpPr>
@@ -8094,7 +7902,7 @@
       </p:sp>
       <p:sp>
         <p:nvSpPr>
-          <p:cNvPr id="24" name="Rectangle 23"/>
+          <p:cNvPr id="23" name="Rectangle 22"/>
           <p:cNvSpPr/>
           <p:nvPr/>
         </p:nvSpPr>
@@ -8138,7 +7946,7 @@
       </p:sp>
       <p:sp>
         <p:nvSpPr>
-          <p:cNvPr id="25" name="TextBox 24"/>
+          <p:cNvPr id="24" name="TextBox 23"/>
           <p:cNvSpPr txBox="1"/>
           <p:nvPr/>
         </p:nvSpPr>
@@ -8186,7 +7994,7 @@
       </p:sp>
       <p:sp>
         <p:nvSpPr>
-          <p:cNvPr id="26" name="TextBox 25"/>
+          <p:cNvPr id="25" name="TextBox 24"/>
           <p:cNvSpPr txBox="1"/>
           <p:nvPr/>
         </p:nvSpPr>
@@ -8234,7 +8042,7 @@
       </p:sp>
       <p:sp>
         <p:nvSpPr>
-          <p:cNvPr id="27" name="TextBox 26"/>
+          <p:cNvPr id="26" name="TextBox 25"/>
           <p:cNvSpPr txBox="1"/>
           <p:nvPr/>
         </p:nvSpPr>
@@ -8282,7 +8090,7 @@
       </p:sp>
       <p:sp>
         <p:nvSpPr>
-          <p:cNvPr id="28" name="Rectangle 27"/>
+          <p:cNvPr id="27" name="Rectangle 26"/>
           <p:cNvSpPr/>
           <p:nvPr/>
         </p:nvSpPr>
@@ -8326,7 +8134,7 @@
       </p:sp>
       <p:sp>
         <p:nvSpPr>
-          <p:cNvPr id="29" name="TextBox 28"/>
+          <p:cNvPr id="28" name="TextBox 27"/>
           <p:cNvSpPr txBox="1"/>
           <p:nvPr/>
         </p:nvSpPr>
@@ -8374,7 +8182,7 @@
       </p:sp>
       <p:sp>
         <p:nvSpPr>
-          <p:cNvPr id="30" name="TextBox 29"/>
+          <p:cNvPr id="29" name="TextBox 28"/>
           <p:cNvSpPr txBox="1"/>
           <p:nvPr/>
         </p:nvSpPr>
@@ -8422,7 +8230,7 @@
       </p:sp>
       <p:sp>
         <p:nvSpPr>
-          <p:cNvPr id="31" name="TextBox 30"/>
+          <p:cNvPr id="30" name="TextBox 29"/>
           <p:cNvSpPr txBox="1"/>
           <p:nvPr/>
         </p:nvSpPr>
@@ -8470,7 +8278,7 @@
       </p:sp>
       <p:sp>
         <p:nvSpPr>
-          <p:cNvPr id="32" name="TextBox 31"/>
+          <p:cNvPr id="31" name="TextBox 30"/>
           <p:cNvSpPr txBox="1"/>
           <p:nvPr/>
         </p:nvSpPr>
@@ -8611,8 +8419,8 @@
         </p:nvSpPr>
         <p:spPr>
           <a:xfrm>
-            <a:off x="548640" y="411479"/>
-            <a:ext cx="8229600" cy="320040"/>
+            <a:off x="548640" y="457200"/>
+            <a:ext cx="11064240" cy="548640"/>
           </a:xfrm>
           <a:prstGeom prst="rect">
             <a:avLst/>
@@ -8632,54 +8440,6 @@
               <a:spcAft>
                 <a:spcPts val="0"/>
               </a:spcAft>
-              <a:defRPr sz="1300" b="1">
-                <a:solidFill>
-                  <a:srgbClr val="FBBF24"/>
-                </a:solidFill>
-                <a:latin typeface="Helvetica Neue"/>
-              </a:defRPr>
-            </a:pPr>
-            <a:r>
-              <a:rPr>
-                <a:solidFill>
-                  <a:srgbClr val="FBBF24"/>
-                </a:solidFill>
-                <a:latin typeface="Helvetica Neue"/>
-              </a:rPr>
-              <a:t>APARTADO 09 · AGREGADOS</a:t>
-            </a:r>
-          </a:p>
-        </p:txBody>
-      </p:sp>
-      <p:sp>
-        <p:nvSpPr>
-          <p:cNvPr id="4" name="TextBox 3"/>
-          <p:cNvSpPr txBox="1"/>
-          <p:nvPr/>
-        </p:nvSpPr>
-        <p:spPr>
-          <a:xfrm>
-            <a:off x="548640" y="676656"/>
-            <a:ext cx="11064240" cy="548640"/>
-          </a:xfrm>
-          <a:prstGeom prst="rect">
-            <a:avLst/>
-          </a:prstGeom>
-          <a:noFill/>
-        </p:spPr>
-        <p:txBody>
-          <a:bodyPr wrap="square" anchor="t" lIns="0" rIns="0" tIns="0" bIns="0">
-            <a:spAutoFit/>
-          </a:bodyPr>
-          <a:lstStyle/>
-          <a:p>
-            <a:pPr algn="l">
-              <a:spcBef>
-                <a:spcPts val="0"/>
-              </a:spcBef>
-              <a:spcAft>
-                <a:spcPts val="0"/>
-              </a:spcAft>
               <a:defRPr sz="3000" b="1">
                 <a:solidFill>
                   <a:srgbClr val="E2E8F0"/>
@@ -8701,13 +8461,13 @@
       </p:sp>
       <p:sp>
         <p:nvSpPr>
-          <p:cNvPr id="5" name="Rectangle 4"/>
+          <p:cNvPr id="4" name="Rectangle 3"/>
           <p:cNvSpPr/>
           <p:nvPr/>
         </p:nvSpPr>
         <p:spPr>
           <a:xfrm>
-            <a:off x="548640" y="1033271"/>
+            <a:off x="548640" y="813816"/>
             <a:ext cx="960120" cy="41148"/>
           </a:xfrm>
           <a:prstGeom prst="rect">
@@ -8745,7 +8505,7 @@
       </p:sp>
       <p:sp>
         <p:nvSpPr>
-          <p:cNvPr id="6" name="Rectangle 5"/>
+          <p:cNvPr id="5" name="Rectangle 4"/>
           <p:cNvSpPr/>
           <p:nvPr/>
         </p:nvSpPr>
@@ -8789,7 +8549,7 @@
       </p:sp>
       <p:sp>
         <p:nvSpPr>
-          <p:cNvPr id="7" name="TextBox 6"/>
+          <p:cNvPr id="6" name="TextBox 5"/>
           <p:cNvSpPr txBox="1"/>
           <p:nvPr/>
         </p:nvSpPr>
@@ -8837,7 +8597,7 @@
       </p:sp>
       <p:sp>
         <p:nvSpPr>
-          <p:cNvPr id="8" name="TextBox 7"/>
+          <p:cNvPr id="7" name="TextBox 6"/>
           <p:cNvSpPr txBox="1"/>
           <p:nvPr/>
         </p:nvSpPr>
@@ -8885,7 +8645,7 @@
       </p:sp>
       <p:sp>
         <p:nvSpPr>
-          <p:cNvPr id="9" name="TextBox 8"/>
+          <p:cNvPr id="8" name="TextBox 7"/>
           <p:cNvSpPr txBox="1"/>
           <p:nvPr/>
         </p:nvSpPr>
@@ -9211,7 +8971,7 @@
       </p:sp>
       <p:sp>
         <p:nvSpPr>
-          <p:cNvPr id="10" name="Rounded Rectangle 9"/>
+          <p:cNvPr id="9" name="Rounded Rectangle 8"/>
           <p:cNvSpPr/>
           <p:nvPr/>
         </p:nvSpPr>
@@ -9257,7 +9017,7 @@
       </p:sp>
       <p:sp>
         <p:nvSpPr>
-          <p:cNvPr id="11" name="TextBox 10"/>
+          <p:cNvPr id="10" name="TextBox 9"/>
           <p:cNvSpPr txBox="1"/>
           <p:nvPr/>
         </p:nvSpPr>
@@ -9380,7 +9140,7 @@
       </p:sp>
       <p:sp>
         <p:nvSpPr>
-          <p:cNvPr id="12" name="Rounded Rectangle 11"/>
+          <p:cNvPr id="11" name="Rounded Rectangle 10"/>
           <p:cNvSpPr/>
           <p:nvPr/>
         </p:nvSpPr>
@@ -9426,7 +9186,7 @@
       </p:sp>
       <p:sp>
         <p:nvSpPr>
-          <p:cNvPr id="13" name="TextBox 12"/>
+          <p:cNvPr id="12" name="TextBox 11"/>
           <p:cNvSpPr txBox="1"/>
           <p:nvPr/>
         </p:nvSpPr>
@@ -9617,8 +9377,8 @@
         </p:nvSpPr>
         <p:spPr>
           <a:xfrm>
-            <a:off x="548640" y="411479"/>
-            <a:ext cx="8229600" cy="320040"/>
+            <a:off x="548640" y="457200"/>
+            <a:ext cx="11064240" cy="548640"/>
           </a:xfrm>
           <a:prstGeom prst="rect">
             <a:avLst/>
@@ -9638,54 +9398,6 @@
               <a:spcAft>
                 <a:spcPts val="0"/>
               </a:spcAft>
-              <a:defRPr sz="1300" b="1">
-                <a:solidFill>
-                  <a:srgbClr val="FBBF24"/>
-                </a:solidFill>
-                <a:latin typeface="Helvetica Neue"/>
-              </a:defRPr>
-            </a:pPr>
-            <a:r>
-              <a:rPr>
-                <a:solidFill>
-                  <a:srgbClr val="FBBF24"/>
-                </a:solidFill>
-                <a:latin typeface="Helvetica Neue"/>
-              </a:rPr>
-              <a:t>APARTADO 10 · BONUS</a:t>
-            </a:r>
-          </a:p>
-        </p:txBody>
-      </p:sp>
-      <p:sp>
-        <p:nvSpPr>
-          <p:cNvPr id="4" name="TextBox 3"/>
-          <p:cNvSpPr txBox="1"/>
-          <p:nvPr/>
-        </p:nvSpPr>
-        <p:spPr>
-          <a:xfrm>
-            <a:off x="548640" y="676656"/>
-            <a:ext cx="11064240" cy="548640"/>
-          </a:xfrm>
-          <a:prstGeom prst="rect">
-            <a:avLst/>
-          </a:prstGeom>
-          <a:noFill/>
-        </p:spPr>
-        <p:txBody>
-          <a:bodyPr wrap="square" anchor="t" lIns="0" rIns="0" tIns="0" bIns="0">
-            <a:spAutoFit/>
-          </a:bodyPr>
-          <a:lstStyle/>
-          <a:p>
-            <a:pPr algn="l">
-              <a:spcBef>
-                <a:spcPts val="0"/>
-              </a:spcBef>
-              <a:spcAft>
-                <a:spcPts val="0"/>
-              </a:spcAft>
               <a:defRPr sz="3000" b="1">
                 <a:solidFill>
                   <a:srgbClr val="E2E8F0"/>
@@ -9707,13 +9419,13 @@
       </p:sp>
       <p:sp>
         <p:nvSpPr>
-          <p:cNvPr id="5" name="Rectangle 4"/>
+          <p:cNvPr id="4" name="Rectangle 3"/>
           <p:cNvSpPr/>
           <p:nvPr/>
         </p:nvSpPr>
         <p:spPr>
           <a:xfrm>
-            <a:off x="548640" y="1033271"/>
+            <a:off x="548640" y="813816"/>
             <a:ext cx="960120" cy="41148"/>
           </a:xfrm>
           <a:prstGeom prst="rect">
@@ -9751,7 +9463,7 @@
       </p:sp>
       <p:sp>
         <p:nvSpPr>
-          <p:cNvPr id="6" name="Rectangle 5"/>
+          <p:cNvPr id="5" name="Rectangle 4"/>
           <p:cNvSpPr/>
           <p:nvPr/>
         </p:nvSpPr>
@@ -9795,7 +9507,7 @@
       </p:sp>
       <p:sp>
         <p:nvSpPr>
-          <p:cNvPr id="7" name="TextBox 6"/>
+          <p:cNvPr id="6" name="TextBox 5"/>
           <p:cNvSpPr txBox="1"/>
           <p:nvPr/>
         </p:nvSpPr>
@@ -9843,7 +9555,7 @@
       </p:sp>
       <p:sp>
         <p:nvSpPr>
-          <p:cNvPr id="8" name="TextBox 7"/>
+          <p:cNvPr id="7" name="TextBox 6"/>
           <p:cNvSpPr txBox="1"/>
           <p:nvPr/>
         </p:nvSpPr>
@@ -9891,7 +9603,7 @@
       </p:sp>
       <p:sp>
         <p:nvSpPr>
-          <p:cNvPr id="9" name="Rounded Rectangle 8"/>
+          <p:cNvPr id="8" name="Rounded Rectangle 7"/>
           <p:cNvSpPr/>
           <p:nvPr/>
         </p:nvSpPr>
@@ -9937,7 +9649,7 @@
       </p:sp>
       <p:sp>
         <p:nvSpPr>
-          <p:cNvPr id="10" name="TextBox 9"/>
+          <p:cNvPr id="9" name="TextBox 8"/>
           <p:cNvSpPr txBox="1"/>
           <p:nvPr/>
         </p:nvSpPr>
@@ -10085,7 +9797,7 @@
       </p:sp>
       <p:sp>
         <p:nvSpPr>
-          <p:cNvPr id="11" name="TextBox 10"/>
+          <p:cNvPr id="10" name="TextBox 9"/>
           <p:cNvSpPr txBox="1"/>
           <p:nvPr/>
         </p:nvSpPr>
@@ -10316,7 +10028,7 @@
       </p:sp>
       <p:sp>
         <p:nvSpPr>
-          <p:cNvPr id="12" name="Rounded Rectangle 11"/>
+          <p:cNvPr id="11" name="Rounded Rectangle 10"/>
           <p:cNvSpPr/>
           <p:nvPr/>
         </p:nvSpPr>
@@ -10362,7 +10074,7 @@
       </p:sp>
       <p:sp>
         <p:nvSpPr>
-          <p:cNvPr id="13" name="TextBox 12"/>
+          <p:cNvPr id="12" name="TextBox 11"/>
           <p:cNvSpPr txBox="1"/>
           <p:nvPr/>
         </p:nvSpPr>
@@ -10553,8 +10265,8 @@
         </p:nvSpPr>
         <p:spPr>
           <a:xfrm>
-            <a:off x="548640" y="411479"/>
-            <a:ext cx="8229600" cy="320040"/>
+            <a:off x="548640" y="457200"/>
+            <a:ext cx="11064240" cy="548640"/>
           </a:xfrm>
           <a:prstGeom prst="rect">
             <a:avLst/>
@@ -10574,54 +10286,6 @@
               <a:spcAft>
                 <a:spcPts val="0"/>
               </a:spcAft>
-              <a:defRPr sz="1300" b="1">
-                <a:solidFill>
-                  <a:srgbClr val="FBBF24"/>
-                </a:solidFill>
-                <a:latin typeface="Helvetica Neue"/>
-              </a:defRPr>
-            </a:pPr>
-            <a:r>
-              <a:rPr>
-                <a:solidFill>
-                  <a:srgbClr val="FBBF24"/>
-                </a:solidFill>
-                <a:latin typeface="Helvetica Neue"/>
-              </a:rPr>
-              <a:t>APARTADO 11 · PARÁMETROS</a:t>
-            </a:r>
-          </a:p>
-        </p:txBody>
-      </p:sp>
-      <p:sp>
-        <p:nvSpPr>
-          <p:cNvPr id="4" name="TextBox 3"/>
-          <p:cNvSpPr txBox="1"/>
-          <p:nvPr/>
-        </p:nvSpPr>
-        <p:spPr>
-          <a:xfrm>
-            <a:off x="548640" y="676656"/>
-            <a:ext cx="11064240" cy="548640"/>
-          </a:xfrm>
-          <a:prstGeom prst="rect">
-            <a:avLst/>
-          </a:prstGeom>
-          <a:noFill/>
-        </p:spPr>
-        <p:txBody>
-          <a:bodyPr wrap="square" anchor="t" lIns="0" rIns="0" tIns="0" bIns="0">
-            <a:spAutoFit/>
-          </a:bodyPr>
-          <a:lstStyle/>
-          <a:p>
-            <a:pPr algn="l">
-              <a:spcBef>
-                <a:spcPts val="0"/>
-              </a:spcBef>
-              <a:spcAft>
-                <a:spcPts val="0"/>
-              </a:spcAft>
               <a:defRPr sz="3000" b="1">
                 <a:solidFill>
                   <a:srgbClr val="E2E8F0"/>
@@ -10643,13 +10307,13 @@
       </p:sp>
       <p:sp>
         <p:nvSpPr>
-          <p:cNvPr id="5" name="Rectangle 4"/>
+          <p:cNvPr id="4" name="Rectangle 3"/>
           <p:cNvSpPr/>
           <p:nvPr/>
         </p:nvSpPr>
         <p:spPr>
           <a:xfrm>
-            <a:off x="548640" y="1033271"/>
+            <a:off x="548640" y="813816"/>
             <a:ext cx="960120" cy="41148"/>
           </a:xfrm>
           <a:prstGeom prst="rect">
@@ -10687,7 +10351,7 @@
       </p:sp>
       <p:sp>
         <p:nvSpPr>
-          <p:cNvPr id="6" name="Rectangle 5"/>
+          <p:cNvPr id="5" name="Rectangle 4"/>
           <p:cNvSpPr/>
           <p:nvPr/>
         </p:nvSpPr>
@@ -10731,7 +10395,7 @@
       </p:sp>
       <p:sp>
         <p:nvSpPr>
-          <p:cNvPr id="7" name="TextBox 6"/>
+          <p:cNvPr id="6" name="TextBox 5"/>
           <p:cNvSpPr txBox="1"/>
           <p:nvPr/>
         </p:nvSpPr>
@@ -10779,7 +10443,7 @@
       </p:sp>
       <p:sp>
         <p:nvSpPr>
-          <p:cNvPr id="8" name="TextBox 7"/>
+          <p:cNvPr id="7" name="TextBox 6"/>
           <p:cNvSpPr txBox="1"/>
           <p:nvPr/>
         </p:nvSpPr>
@@ -10827,7 +10491,7 @@
       </p:sp>
       <p:sp>
         <p:nvSpPr>
-          <p:cNvPr id="9" name="Rectangle 8"/>
+          <p:cNvPr id="8" name="Rectangle 7"/>
           <p:cNvSpPr/>
           <p:nvPr/>
         </p:nvSpPr>
@@ -10871,7 +10535,7 @@
       </p:sp>
       <p:sp>
         <p:nvSpPr>
-          <p:cNvPr id="10" name="TextBox 9"/>
+          <p:cNvPr id="9" name="TextBox 8"/>
           <p:cNvSpPr txBox="1"/>
           <p:nvPr/>
         </p:nvSpPr>
@@ -10919,7 +10583,7 @@
       </p:sp>
       <p:sp>
         <p:nvSpPr>
-          <p:cNvPr id="11" name="TextBox 10"/>
+          <p:cNvPr id="10" name="TextBox 9"/>
           <p:cNvSpPr txBox="1"/>
           <p:nvPr/>
         </p:nvSpPr>
@@ -10967,7 +10631,7 @@
       </p:sp>
       <p:sp>
         <p:nvSpPr>
-          <p:cNvPr id="12" name="TextBox 11"/>
+          <p:cNvPr id="11" name="TextBox 10"/>
           <p:cNvSpPr txBox="1"/>
           <p:nvPr/>
         </p:nvSpPr>
@@ -11015,7 +10679,7 @@
       </p:sp>
       <p:sp>
         <p:nvSpPr>
-          <p:cNvPr id="13" name="Rectangle 12"/>
+          <p:cNvPr id="12" name="Rectangle 11"/>
           <p:cNvSpPr/>
           <p:nvPr/>
         </p:nvSpPr>
@@ -11059,7 +10723,7 @@
       </p:sp>
       <p:sp>
         <p:nvSpPr>
-          <p:cNvPr id="14" name="TextBox 13"/>
+          <p:cNvPr id="13" name="TextBox 12"/>
           <p:cNvSpPr txBox="1"/>
           <p:nvPr/>
         </p:nvSpPr>
@@ -11107,7 +10771,7 @@
       </p:sp>
       <p:sp>
         <p:nvSpPr>
-          <p:cNvPr id="15" name="TextBox 14"/>
+          <p:cNvPr id="14" name="TextBox 13"/>
           <p:cNvSpPr txBox="1"/>
           <p:nvPr/>
         </p:nvSpPr>
@@ -11155,7 +10819,7 @@
       </p:sp>
       <p:sp>
         <p:nvSpPr>
-          <p:cNvPr id="16" name="TextBox 15"/>
+          <p:cNvPr id="15" name="TextBox 14"/>
           <p:cNvSpPr txBox="1"/>
           <p:nvPr/>
         </p:nvSpPr>
@@ -11203,7 +10867,7 @@
       </p:sp>
       <p:sp>
         <p:nvSpPr>
-          <p:cNvPr id="17" name="Rectangle 16"/>
+          <p:cNvPr id="16" name="Rectangle 15"/>
           <p:cNvSpPr/>
           <p:nvPr/>
         </p:nvSpPr>
@@ -11247,7 +10911,7 @@
       </p:sp>
       <p:sp>
         <p:nvSpPr>
-          <p:cNvPr id="18" name="TextBox 17"/>
+          <p:cNvPr id="17" name="TextBox 16"/>
           <p:cNvSpPr txBox="1"/>
           <p:nvPr/>
         </p:nvSpPr>
@@ -11295,7 +10959,7 @@
       </p:sp>
       <p:sp>
         <p:nvSpPr>
-          <p:cNvPr id="19" name="TextBox 18"/>
+          <p:cNvPr id="18" name="TextBox 17"/>
           <p:cNvSpPr txBox="1"/>
           <p:nvPr/>
         </p:nvSpPr>
@@ -11343,7 +11007,7 @@
       </p:sp>
       <p:sp>
         <p:nvSpPr>
-          <p:cNvPr id="20" name="TextBox 19"/>
+          <p:cNvPr id="19" name="TextBox 18"/>
           <p:cNvSpPr txBox="1"/>
           <p:nvPr/>
         </p:nvSpPr>
@@ -11391,7 +11055,7 @@
       </p:sp>
       <p:sp>
         <p:nvSpPr>
-          <p:cNvPr id="21" name="Rectangle 20"/>
+          <p:cNvPr id="20" name="Rectangle 19"/>
           <p:cNvSpPr/>
           <p:nvPr/>
         </p:nvSpPr>
@@ -11435,7 +11099,7 @@
       </p:sp>
       <p:sp>
         <p:nvSpPr>
-          <p:cNvPr id="22" name="TextBox 21"/>
+          <p:cNvPr id="21" name="TextBox 20"/>
           <p:cNvSpPr txBox="1"/>
           <p:nvPr/>
         </p:nvSpPr>
@@ -11483,7 +11147,7 @@
       </p:sp>
       <p:sp>
         <p:nvSpPr>
-          <p:cNvPr id="23" name="TextBox 22"/>
+          <p:cNvPr id="22" name="TextBox 21"/>
           <p:cNvSpPr txBox="1"/>
           <p:nvPr/>
         </p:nvSpPr>
@@ -11531,7 +11195,7 @@
       </p:sp>
       <p:sp>
         <p:nvSpPr>
-          <p:cNvPr id="24" name="TextBox 23"/>
+          <p:cNvPr id="23" name="TextBox 22"/>
           <p:cNvSpPr txBox="1"/>
           <p:nvPr/>
         </p:nvSpPr>
@@ -11579,7 +11243,7 @@
       </p:sp>
       <p:sp>
         <p:nvSpPr>
-          <p:cNvPr id="25" name="Rectangle 24"/>
+          <p:cNvPr id="24" name="Rectangle 23"/>
           <p:cNvSpPr/>
           <p:nvPr/>
         </p:nvSpPr>
@@ -11623,7 +11287,7 @@
       </p:sp>
       <p:sp>
         <p:nvSpPr>
-          <p:cNvPr id="26" name="TextBox 25"/>
+          <p:cNvPr id="25" name="TextBox 24"/>
           <p:cNvSpPr txBox="1"/>
           <p:nvPr/>
         </p:nvSpPr>
@@ -11671,7 +11335,7 @@
       </p:sp>
       <p:sp>
         <p:nvSpPr>
-          <p:cNvPr id="27" name="TextBox 26"/>
+          <p:cNvPr id="26" name="TextBox 25"/>
           <p:cNvSpPr txBox="1"/>
           <p:nvPr/>
         </p:nvSpPr>
@@ -11719,7 +11383,7 @@
       </p:sp>
       <p:sp>
         <p:nvSpPr>
-          <p:cNvPr id="28" name="TextBox 27"/>
+          <p:cNvPr id="27" name="TextBox 26"/>
           <p:cNvSpPr txBox="1"/>
           <p:nvPr/>
         </p:nvSpPr>
@@ -11767,7 +11431,7 @@
       </p:sp>
       <p:sp>
         <p:nvSpPr>
-          <p:cNvPr id="29" name="Rectangle 28"/>
+          <p:cNvPr id="28" name="Rectangle 27"/>
           <p:cNvSpPr/>
           <p:nvPr/>
         </p:nvSpPr>
@@ -11811,7 +11475,7 @@
       </p:sp>
       <p:sp>
         <p:nvSpPr>
-          <p:cNvPr id="30" name="TextBox 29"/>
+          <p:cNvPr id="29" name="TextBox 28"/>
           <p:cNvSpPr txBox="1"/>
           <p:nvPr/>
         </p:nvSpPr>
@@ -11859,7 +11523,7 @@
       </p:sp>
       <p:sp>
         <p:nvSpPr>
-          <p:cNvPr id="31" name="TextBox 30"/>
+          <p:cNvPr id="30" name="TextBox 29"/>
           <p:cNvSpPr txBox="1"/>
           <p:nvPr/>
         </p:nvSpPr>
@@ -11907,7 +11571,7 @@
       </p:sp>
       <p:sp>
         <p:nvSpPr>
-          <p:cNvPr id="32" name="TextBox 31"/>
+          <p:cNvPr id="31" name="TextBox 30"/>
           <p:cNvSpPr txBox="1"/>
           <p:nvPr/>
         </p:nvSpPr>
@@ -11955,7 +11619,7 @@
       </p:sp>
       <p:sp>
         <p:nvSpPr>
-          <p:cNvPr id="33" name="Rectangle 32"/>
+          <p:cNvPr id="32" name="Rectangle 31"/>
           <p:cNvSpPr/>
           <p:nvPr/>
         </p:nvSpPr>
@@ -11999,7 +11663,7 @@
       </p:sp>
       <p:sp>
         <p:nvSpPr>
-          <p:cNvPr id="34" name="TextBox 33"/>
+          <p:cNvPr id="33" name="TextBox 32"/>
           <p:cNvSpPr txBox="1"/>
           <p:nvPr/>
         </p:nvSpPr>
@@ -12047,7 +11711,7 @@
       </p:sp>
       <p:sp>
         <p:nvSpPr>
-          <p:cNvPr id="35" name="TextBox 34"/>
+          <p:cNvPr id="34" name="TextBox 33"/>
           <p:cNvSpPr txBox="1"/>
           <p:nvPr/>
         </p:nvSpPr>
@@ -12095,7 +11759,7 @@
       </p:sp>
       <p:sp>
         <p:nvSpPr>
-          <p:cNvPr id="36" name="TextBox 35"/>
+          <p:cNvPr id="35" name="TextBox 34"/>
           <p:cNvSpPr txBox="1"/>
           <p:nvPr/>
         </p:nvSpPr>
@@ -12143,7 +11807,7 @@
       </p:sp>
       <p:sp>
         <p:nvSpPr>
-          <p:cNvPr id="37" name="Rectangle 36"/>
+          <p:cNvPr id="36" name="Rectangle 35"/>
           <p:cNvSpPr/>
           <p:nvPr/>
         </p:nvSpPr>
@@ -12187,7 +11851,7 @@
       </p:sp>
       <p:sp>
         <p:nvSpPr>
-          <p:cNvPr id="38" name="TextBox 37"/>
+          <p:cNvPr id="37" name="TextBox 36"/>
           <p:cNvSpPr txBox="1"/>
           <p:nvPr/>
         </p:nvSpPr>
@@ -12235,7 +11899,7 @@
       </p:sp>
       <p:sp>
         <p:nvSpPr>
-          <p:cNvPr id="39" name="TextBox 38"/>
+          <p:cNvPr id="38" name="TextBox 37"/>
           <p:cNvSpPr txBox="1"/>
           <p:nvPr/>
         </p:nvSpPr>
@@ -12283,7 +11947,7 @@
       </p:sp>
       <p:sp>
         <p:nvSpPr>
-          <p:cNvPr id="40" name="TextBox 39"/>
+          <p:cNvPr id="39" name="TextBox 38"/>
           <p:cNvSpPr txBox="1"/>
           <p:nvPr/>
         </p:nvSpPr>
@@ -12331,7 +11995,7 @@
       </p:sp>
       <p:sp>
         <p:nvSpPr>
-          <p:cNvPr id="41" name="Rectangle 40"/>
+          <p:cNvPr id="40" name="Rectangle 39"/>
           <p:cNvSpPr/>
           <p:nvPr/>
         </p:nvSpPr>
@@ -12375,7 +12039,7 @@
       </p:sp>
       <p:sp>
         <p:nvSpPr>
-          <p:cNvPr id="42" name="TextBox 41"/>
+          <p:cNvPr id="41" name="TextBox 40"/>
           <p:cNvSpPr txBox="1"/>
           <p:nvPr/>
         </p:nvSpPr>
@@ -12423,7 +12087,7 @@
       </p:sp>
       <p:sp>
         <p:nvSpPr>
-          <p:cNvPr id="43" name="TextBox 42"/>
+          <p:cNvPr id="42" name="TextBox 41"/>
           <p:cNvSpPr txBox="1"/>
           <p:nvPr/>
         </p:nvSpPr>
@@ -12471,7 +12135,7 @@
       </p:sp>
       <p:sp>
         <p:nvSpPr>
-          <p:cNvPr id="44" name="TextBox 43"/>
+          <p:cNvPr id="43" name="TextBox 42"/>
           <p:cNvSpPr txBox="1"/>
           <p:nvPr/>
         </p:nvSpPr>
@@ -12519,7 +12183,7 @@
       </p:sp>
       <p:sp>
         <p:nvSpPr>
-          <p:cNvPr id="45" name="TextBox 44"/>
+          <p:cNvPr id="44" name="TextBox 43"/>
           <p:cNvSpPr txBox="1"/>
           <p:nvPr/>
         </p:nvSpPr>
@@ -12705,8 +12369,8 @@
         </p:nvSpPr>
         <p:spPr>
           <a:xfrm>
-            <a:off x="548640" y="411479"/>
-            <a:ext cx="8229600" cy="320040"/>
+            <a:off x="548640" y="457200"/>
+            <a:ext cx="11064240" cy="548640"/>
           </a:xfrm>
           <a:prstGeom prst="rect">
             <a:avLst/>
@@ -12726,54 +12390,6 @@
               <a:spcAft>
                 <a:spcPts val="0"/>
               </a:spcAft>
-              <a:defRPr sz="1300" b="1">
-                <a:solidFill>
-                  <a:srgbClr val="FBBF24"/>
-                </a:solidFill>
-                <a:latin typeface="Helvetica Neue"/>
-              </a:defRPr>
-            </a:pPr>
-            <a:r>
-              <a:rPr>
-                <a:solidFill>
-                  <a:srgbClr val="FBBF24"/>
-                </a:solidFill>
-                <a:latin typeface="Helvetica Neue"/>
-              </a:rPr>
-              <a:t>RESUMEN</a:t>
-            </a:r>
-          </a:p>
-        </p:txBody>
-      </p:sp>
-      <p:sp>
-        <p:nvSpPr>
-          <p:cNvPr id="4" name="TextBox 3"/>
-          <p:cNvSpPr txBox="1"/>
-          <p:nvPr/>
-        </p:nvSpPr>
-        <p:spPr>
-          <a:xfrm>
-            <a:off x="548640" y="676656"/>
-            <a:ext cx="11064240" cy="548640"/>
-          </a:xfrm>
-          <a:prstGeom prst="rect">
-            <a:avLst/>
-          </a:prstGeom>
-          <a:noFill/>
-        </p:spPr>
-        <p:txBody>
-          <a:bodyPr wrap="square" anchor="t" lIns="0" rIns="0" tIns="0" bIns="0">
-            <a:spAutoFit/>
-          </a:bodyPr>
-          <a:lstStyle/>
-          <a:p>
-            <a:pPr algn="l">
-              <a:spcBef>
-                <a:spcPts val="0"/>
-              </a:spcBef>
-              <a:spcAft>
-                <a:spcPts val="0"/>
-              </a:spcAft>
               <a:defRPr sz="3000" b="1">
                 <a:solidFill>
                   <a:srgbClr val="E2E8F0"/>
@@ -12795,13 +12411,13 @@
       </p:sp>
       <p:sp>
         <p:nvSpPr>
-          <p:cNvPr id="5" name="Rectangle 4"/>
+          <p:cNvPr id="4" name="Rectangle 3"/>
           <p:cNvSpPr/>
           <p:nvPr/>
         </p:nvSpPr>
         <p:spPr>
           <a:xfrm>
-            <a:off x="548640" y="1033271"/>
+            <a:off x="548640" y="813816"/>
             <a:ext cx="960120" cy="41148"/>
           </a:xfrm>
           <a:prstGeom prst="rect">
@@ -12839,7 +12455,7 @@
       </p:sp>
       <p:sp>
         <p:nvSpPr>
-          <p:cNvPr id="6" name="Rectangle 5"/>
+          <p:cNvPr id="5" name="Rectangle 4"/>
           <p:cNvSpPr/>
           <p:nvPr/>
         </p:nvSpPr>
@@ -12883,7 +12499,7 @@
       </p:sp>
       <p:sp>
         <p:nvSpPr>
-          <p:cNvPr id="7" name="TextBox 6"/>
+          <p:cNvPr id="6" name="TextBox 5"/>
           <p:cNvSpPr txBox="1"/>
           <p:nvPr/>
         </p:nvSpPr>
@@ -12931,7 +12547,7 @@
       </p:sp>
       <p:sp>
         <p:nvSpPr>
-          <p:cNvPr id="8" name="TextBox 7"/>
+          <p:cNvPr id="7" name="TextBox 6"/>
           <p:cNvSpPr txBox="1"/>
           <p:nvPr/>
         </p:nvSpPr>
@@ -12979,7 +12595,7 @@
       </p:sp>
       <p:sp>
         <p:nvSpPr>
-          <p:cNvPr id="9" name="Rounded Rectangle 8"/>
+          <p:cNvPr id="8" name="Rounded Rectangle 7"/>
           <p:cNvSpPr/>
           <p:nvPr/>
         </p:nvSpPr>
@@ -13025,7 +12641,7 @@
       </p:sp>
       <p:sp>
         <p:nvSpPr>
-          <p:cNvPr id="10" name="TextBox 9"/>
+          <p:cNvPr id="9" name="TextBox 8"/>
           <p:cNvSpPr txBox="1"/>
           <p:nvPr/>
         </p:nvSpPr>
@@ -13073,7 +12689,7 @@
       </p:sp>
       <p:sp>
         <p:nvSpPr>
-          <p:cNvPr id="11" name="TextBox 10"/>
+          <p:cNvPr id="10" name="TextBox 9"/>
           <p:cNvSpPr txBox="1"/>
           <p:nvPr/>
         </p:nvSpPr>
@@ -13121,7 +12737,7 @@
       </p:sp>
       <p:sp>
         <p:nvSpPr>
-          <p:cNvPr id="12" name="Rounded Rectangle 11"/>
+          <p:cNvPr id="11" name="Rounded Rectangle 10"/>
           <p:cNvSpPr/>
           <p:nvPr/>
         </p:nvSpPr>
@@ -13167,7 +12783,7 @@
       </p:sp>
       <p:sp>
         <p:nvSpPr>
-          <p:cNvPr id="13" name="TextBox 12"/>
+          <p:cNvPr id="12" name="TextBox 11"/>
           <p:cNvSpPr txBox="1"/>
           <p:nvPr/>
         </p:nvSpPr>
@@ -13215,7 +12831,7 @@
       </p:sp>
       <p:sp>
         <p:nvSpPr>
-          <p:cNvPr id="14" name="TextBox 13"/>
+          <p:cNvPr id="13" name="TextBox 12"/>
           <p:cNvSpPr txBox="1"/>
           <p:nvPr/>
         </p:nvSpPr>
@@ -13263,7 +12879,7 @@
       </p:sp>
       <p:sp>
         <p:nvSpPr>
-          <p:cNvPr id="15" name="Rounded Rectangle 14"/>
+          <p:cNvPr id="14" name="Rounded Rectangle 13"/>
           <p:cNvSpPr/>
           <p:nvPr/>
         </p:nvSpPr>
@@ -13309,7 +12925,7 @@
       </p:sp>
       <p:sp>
         <p:nvSpPr>
-          <p:cNvPr id="16" name="TextBox 15"/>
+          <p:cNvPr id="15" name="TextBox 14"/>
           <p:cNvSpPr txBox="1"/>
           <p:nvPr/>
         </p:nvSpPr>
@@ -13357,7 +12973,7 @@
       </p:sp>
       <p:sp>
         <p:nvSpPr>
-          <p:cNvPr id="17" name="TextBox 16"/>
+          <p:cNvPr id="16" name="TextBox 15"/>
           <p:cNvSpPr txBox="1"/>
           <p:nvPr/>
         </p:nvSpPr>
@@ -13405,7 +13021,7 @@
       </p:sp>
       <p:sp>
         <p:nvSpPr>
-          <p:cNvPr id="18" name="Rounded Rectangle 17"/>
+          <p:cNvPr id="17" name="Rounded Rectangle 16"/>
           <p:cNvSpPr/>
           <p:nvPr/>
         </p:nvSpPr>
@@ -13451,7 +13067,7 @@
       </p:sp>
       <p:sp>
         <p:nvSpPr>
-          <p:cNvPr id="19" name="TextBox 18"/>
+          <p:cNvPr id="18" name="TextBox 17"/>
           <p:cNvSpPr txBox="1"/>
           <p:nvPr/>
         </p:nvSpPr>
@@ -13499,7 +13115,7 @@
       </p:sp>
       <p:sp>
         <p:nvSpPr>
-          <p:cNvPr id="20" name="TextBox 19"/>
+          <p:cNvPr id="19" name="TextBox 18"/>
           <p:cNvSpPr txBox="1"/>
           <p:nvPr/>
         </p:nvSpPr>
@@ -13547,7 +13163,7 @@
       </p:sp>
       <p:sp>
         <p:nvSpPr>
-          <p:cNvPr id="21" name="Rounded Rectangle 20"/>
+          <p:cNvPr id="20" name="Rounded Rectangle 19"/>
           <p:cNvSpPr/>
           <p:nvPr/>
         </p:nvSpPr>
@@ -13593,7 +13209,7 @@
       </p:sp>
       <p:sp>
         <p:nvSpPr>
-          <p:cNvPr id="22" name="TextBox 21"/>
+          <p:cNvPr id="21" name="TextBox 20"/>
           <p:cNvSpPr txBox="1"/>
           <p:nvPr/>
         </p:nvSpPr>
@@ -13641,7 +13257,7 @@
       </p:sp>
       <p:sp>
         <p:nvSpPr>
-          <p:cNvPr id="23" name="TextBox 22"/>
+          <p:cNvPr id="22" name="TextBox 21"/>
           <p:cNvSpPr txBox="1"/>
           <p:nvPr/>
         </p:nvSpPr>
@@ -13689,7 +13305,7 @@
       </p:sp>
       <p:sp>
         <p:nvSpPr>
-          <p:cNvPr id="24" name="Rounded Rectangle 23"/>
+          <p:cNvPr id="23" name="Rounded Rectangle 22"/>
           <p:cNvSpPr/>
           <p:nvPr/>
         </p:nvSpPr>
@@ -13735,7 +13351,7 @@
       </p:sp>
       <p:sp>
         <p:nvSpPr>
-          <p:cNvPr id="25" name="TextBox 24"/>
+          <p:cNvPr id="24" name="TextBox 23"/>
           <p:cNvSpPr txBox="1"/>
           <p:nvPr/>
         </p:nvSpPr>
@@ -13783,7 +13399,7 @@
       </p:sp>
       <p:sp>
         <p:nvSpPr>
-          <p:cNvPr id="26" name="TextBox 25"/>
+          <p:cNvPr id="25" name="TextBox 24"/>
           <p:cNvSpPr txBox="1"/>
           <p:nvPr/>
         </p:nvSpPr>
@@ -13831,7 +13447,7 @@
       </p:sp>
       <p:sp>
         <p:nvSpPr>
-          <p:cNvPr id="27" name="TextBox 26"/>
+          <p:cNvPr id="26" name="TextBox 25"/>
           <p:cNvSpPr txBox="1"/>
           <p:nvPr/>
         </p:nvSpPr>
@@ -13879,7 +13495,7 @@
       </p:sp>
       <p:sp>
         <p:nvSpPr>
-          <p:cNvPr id="28" name="TextBox 27"/>
+          <p:cNvPr id="27" name="TextBox 26"/>
           <p:cNvSpPr txBox="1"/>
           <p:nvPr/>
         </p:nvSpPr>
@@ -14042,7 +13658,7 @@
       </p:sp>
       <p:sp>
         <p:nvSpPr>
-          <p:cNvPr id="29" name="TextBox 28"/>
+          <p:cNvPr id="28" name="TextBox 27"/>
           <p:cNvSpPr txBox="1"/>
           <p:nvPr/>
         </p:nvSpPr>
@@ -14674,8 +14290,8 @@
         </p:nvSpPr>
         <p:spPr>
           <a:xfrm>
-            <a:off x="548640" y="411479"/>
-            <a:ext cx="8229600" cy="320040"/>
+            <a:off x="548640" y="457200"/>
+            <a:ext cx="11064240" cy="548640"/>
           </a:xfrm>
           <a:prstGeom prst="rect">
             <a:avLst/>
@@ -14695,54 +14311,6 @@
               <a:spcAft>
                 <a:spcPts val="0"/>
               </a:spcAft>
-              <a:defRPr sz="1300" b="1">
-                <a:solidFill>
-                  <a:srgbClr val="FBBF24"/>
-                </a:solidFill>
-                <a:latin typeface="Helvetica Neue"/>
-              </a:defRPr>
-            </a:pPr>
-            <a:r>
-              <a:rPr>
-                <a:solidFill>
-                  <a:srgbClr val="FBBF24"/>
-                </a:solidFill>
-                <a:latin typeface="Helvetica Neue"/>
-              </a:rPr>
-              <a:t>ASÍ ABRIMOS</a:t>
-            </a:r>
-          </a:p>
-        </p:txBody>
-      </p:sp>
-      <p:sp>
-        <p:nvSpPr>
-          <p:cNvPr id="4" name="TextBox 3"/>
-          <p:cNvSpPr txBox="1"/>
-          <p:nvPr/>
-        </p:nvSpPr>
-        <p:spPr>
-          <a:xfrm>
-            <a:off x="548640" y="676656"/>
-            <a:ext cx="11064240" cy="548640"/>
-          </a:xfrm>
-          <a:prstGeom prst="rect">
-            <a:avLst/>
-          </a:prstGeom>
-          <a:noFill/>
-        </p:spPr>
-        <p:txBody>
-          <a:bodyPr wrap="square" anchor="t" lIns="0" rIns="0" tIns="0" bIns="0">
-            <a:spAutoFit/>
-          </a:bodyPr>
-          <a:lstStyle/>
-          <a:p>
-            <a:pPr algn="l">
-              <a:spcBef>
-                <a:spcPts val="0"/>
-              </a:spcBef>
-              <a:spcAft>
-                <a:spcPts val="0"/>
-              </a:spcAft>
               <a:defRPr sz="3000" b="1">
                 <a:solidFill>
                   <a:srgbClr val="E2E8F0"/>
@@ -14764,13 +14332,13 @@
       </p:sp>
       <p:sp>
         <p:nvSpPr>
-          <p:cNvPr id="5" name="Rectangle 4"/>
+          <p:cNvPr id="4" name="Rectangle 3"/>
           <p:cNvSpPr/>
           <p:nvPr/>
         </p:nvSpPr>
         <p:spPr>
           <a:xfrm>
-            <a:off x="548640" y="1033271"/>
+            <a:off x="548640" y="813816"/>
             <a:ext cx="960120" cy="41148"/>
           </a:xfrm>
           <a:prstGeom prst="rect">
@@ -14808,7 +14376,7 @@
       </p:sp>
       <p:sp>
         <p:nvSpPr>
-          <p:cNvPr id="6" name="Rectangle 5"/>
+          <p:cNvPr id="5" name="Rectangle 4"/>
           <p:cNvSpPr/>
           <p:nvPr/>
         </p:nvSpPr>
@@ -14852,7 +14420,7 @@
       </p:sp>
       <p:sp>
         <p:nvSpPr>
-          <p:cNvPr id="7" name="TextBox 6"/>
+          <p:cNvPr id="6" name="TextBox 5"/>
           <p:cNvSpPr txBox="1"/>
           <p:nvPr/>
         </p:nvSpPr>
@@ -14900,7 +14468,7 @@
       </p:sp>
       <p:sp>
         <p:nvSpPr>
-          <p:cNvPr id="8" name="TextBox 7"/>
+          <p:cNvPr id="7" name="TextBox 6"/>
           <p:cNvSpPr txBox="1"/>
           <p:nvPr/>
         </p:nvSpPr>
@@ -14948,7 +14516,7 @@
       </p:sp>
       <p:sp>
         <p:nvSpPr>
-          <p:cNvPr id="9" name="TextBox 8"/>
+          <p:cNvPr id="8" name="TextBox 7"/>
           <p:cNvSpPr txBox="1"/>
           <p:nvPr/>
         </p:nvSpPr>
@@ -15166,8 +14734,8 @@
         </p:nvSpPr>
         <p:spPr>
           <a:xfrm>
-            <a:off x="548640" y="411479"/>
-            <a:ext cx="8229600" cy="320040"/>
+            <a:off x="548640" y="457200"/>
+            <a:ext cx="11064240" cy="548640"/>
           </a:xfrm>
           <a:prstGeom prst="rect">
             <a:avLst/>
@@ -15187,54 +14755,6 @@
               <a:spcAft>
                 <a:spcPts val="0"/>
               </a:spcAft>
-              <a:defRPr sz="1300" b="1">
-                <a:solidFill>
-                  <a:srgbClr val="FBBF24"/>
-                </a:solidFill>
-                <a:latin typeface="Helvetica Neue"/>
-              </a:defRPr>
-            </a:pPr>
-            <a:r>
-              <a:rPr>
-                <a:solidFill>
-                  <a:srgbClr val="FBBF24"/>
-                </a:solidFill>
-                <a:latin typeface="Helvetica Neue"/>
-              </a:rPr>
-              <a:t>25 MINUTOS</a:t>
-            </a:r>
-          </a:p>
-        </p:txBody>
-      </p:sp>
-      <p:sp>
-        <p:nvSpPr>
-          <p:cNvPr id="4" name="TextBox 3"/>
-          <p:cNvSpPr txBox="1"/>
-          <p:nvPr/>
-        </p:nvSpPr>
-        <p:spPr>
-          <a:xfrm>
-            <a:off x="548640" y="676656"/>
-            <a:ext cx="11064240" cy="548640"/>
-          </a:xfrm>
-          <a:prstGeom prst="rect">
-            <a:avLst/>
-          </a:prstGeom>
-          <a:noFill/>
-        </p:spPr>
-        <p:txBody>
-          <a:bodyPr wrap="square" anchor="t" lIns="0" rIns="0" tIns="0" bIns="0">
-            <a:spAutoFit/>
-          </a:bodyPr>
-          <a:lstStyle/>
-          <a:p>
-            <a:pPr algn="l">
-              <a:spcBef>
-                <a:spcPts val="0"/>
-              </a:spcBef>
-              <a:spcAft>
-                <a:spcPts val="0"/>
-              </a:spcAft>
               <a:defRPr sz="3000" b="1">
                 <a:solidFill>
                   <a:srgbClr val="E2E8F0"/>
@@ -15256,13 +14776,13 @@
       </p:sp>
       <p:sp>
         <p:nvSpPr>
-          <p:cNvPr id="5" name="Rectangle 4"/>
+          <p:cNvPr id="4" name="Rectangle 3"/>
           <p:cNvSpPr/>
           <p:nvPr/>
         </p:nvSpPr>
         <p:spPr>
           <a:xfrm>
-            <a:off x="548640" y="1033271"/>
+            <a:off x="548640" y="813816"/>
             <a:ext cx="960120" cy="41148"/>
           </a:xfrm>
           <a:prstGeom prst="rect">
@@ -15300,7 +14820,7 @@
       </p:sp>
       <p:sp>
         <p:nvSpPr>
-          <p:cNvPr id="6" name="Rectangle 5"/>
+          <p:cNvPr id="5" name="Rectangle 4"/>
           <p:cNvSpPr/>
           <p:nvPr/>
         </p:nvSpPr>
@@ -15344,7 +14864,7 @@
       </p:sp>
       <p:sp>
         <p:nvSpPr>
-          <p:cNvPr id="7" name="TextBox 6"/>
+          <p:cNvPr id="6" name="TextBox 5"/>
           <p:cNvSpPr txBox="1"/>
           <p:nvPr/>
         </p:nvSpPr>
@@ -15392,7 +14912,7 @@
       </p:sp>
       <p:sp>
         <p:nvSpPr>
-          <p:cNvPr id="8" name="TextBox 7"/>
+          <p:cNvPr id="7" name="TextBox 6"/>
           <p:cNvSpPr txBox="1"/>
           <p:nvPr/>
         </p:nvSpPr>
@@ -15440,7 +14960,7 @@
       </p:sp>
       <p:sp>
         <p:nvSpPr>
-          <p:cNvPr id="9" name="TextBox 8"/>
+          <p:cNvPr id="8" name="TextBox 7"/>
           <p:cNvSpPr txBox="1"/>
           <p:nvPr/>
         </p:nvSpPr>
@@ -15613,7 +15133,7 @@
       </p:sp>
       <p:sp>
         <p:nvSpPr>
-          <p:cNvPr id="10" name="TextBox 9"/>
+          <p:cNvPr id="9" name="TextBox 8"/>
           <p:cNvSpPr txBox="1"/>
           <p:nvPr/>
         </p:nvSpPr>
@@ -15786,7 +15306,7 @@
       </p:sp>
       <p:sp>
         <p:nvSpPr>
-          <p:cNvPr id="11" name="TextBox 10"/>
+          <p:cNvPr id="10" name="TextBox 9"/>
           <p:cNvSpPr txBox="1"/>
           <p:nvPr/>
         </p:nvSpPr>
@@ -15902,8 +15422,8 @@
         </p:nvSpPr>
         <p:spPr>
           <a:xfrm>
-            <a:off x="548640" y="411479"/>
-            <a:ext cx="8229600" cy="320040"/>
+            <a:off x="548640" y="457200"/>
+            <a:ext cx="11064240" cy="548640"/>
           </a:xfrm>
           <a:prstGeom prst="rect">
             <a:avLst/>
@@ -15923,54 +15443,6 @@
               <a:spcAft>
                 <a:spcPts val="0"/>
               </a:spcAft>
-              <a:defRPr sz="1300" b="1">
-                <a:solidFill>
-                  <a:srgbClr val="FBBF24"/>
-                </a:solidFill>
-                <a:latin typeface="Helvetica Neue"/>
-              </a:defRPr>
-            </a:pPr>
-            <a:r>
-              <a:rPr>
-                <a:solidFill>
-                  <a:srgbClr val="FBBF24"/>
-                </a:solidFill>
-                <a:latin typeface="Helvetica Neue"/>
-              </a:rPr>
-              <a:t>APARTADO 00 · CONTEXTO</a:t>
-            </a:r>
-          </a:p>
-        </p:txBody>
-      </p:sp>
-      <p:sp>
-        <p:nvSpPr>
-          <p:cNvPr id="4" name="TextBox 3"/>
-          <p:cNvSpPr txBox="1"/>
-          <p:nvPr/>
-        </p:nvSpPr>
-        <p:spPr>
-          <a:xfrm>
-            <a:off x="548640" y="676656"/>
-            <a:ext cx="11064240" cy="548640"/>
-          </a:xfrm>
-          <a:prstGeom prst="rect">
-            <a:avLst/>
-          </a:prstGeom>
-          <a:noFill/>
-        </p:spPr>
-        <p:txBody>
-          <a:bodyPr wrap="square" anchor="t" lIns="0" rIns="0" tIns="0" bIns="0">
-            <a:spAutoFit/>
-          </a:bodyPr>
-          <a:lstStyle/>
-          <a:p>
-            <a:pPr algn="l">
-              <a:spcBef>
-                <a:spcPts val="0"/>
-              </a:spcBef>
-              <a:spcAft>
-                <a:spcPts val="0"/>
-              </a:spcAft>
               <a:defRPr sz="3000" b="1">
                 <a:solidFill>
                   <a:srgbClr val="E2E8F0"/>
@@ -15985,20 +15457,20 @@
                 </a:solidFill>
                 <a:latin typeface="Helvetica Neue"/>
               </a:rPr>
-              <a:t>¿Qué tiene de especial un dato 'de serie temporal'?</a:t>
-            </a:r>
-          </a:p>
-        </p:txBody>
-      </p:sp>
-      <p:sp>
-        <p:nvSpPr>
-          <p:cNvPr id="5" name="Rectangle 4"/>
+              <a:t>TimescaleDB: el dato de serie temporal nativo de PostgreSQL</a:t>
+            </a:r>
+          </a:p>
+        </p:txBody>
+      </p:sp>
+      <p:sp>
+        <p:nvSpPr>
+          <p:cNvPr id="4" name="Rectangle 3"/>
           <p:cNvSpPr/>
           <p:nvPr/>
         </p:nvSpPr>
         <p:spPr>
           <a:xfrm>
-            <a:off x="548640" y="1033271"/>
+            <a:off x="548640" y="813816"/>
             <a:ext cx="960120" cy="41148"/>
           </a:xfrm>
           <a:prstGeom prst="rect">
@@ -16036,7 +15508,7 @@
       </p:sp>
       <p:sp>
         <p:nvSpPr>
-          <p:cNvPr id="6" name="Rectangle 5"/>
+          <p:cNvPr id="5" name="Rectangle 4"/>
           <p:cNvSpPr/>
           <p:nvPr/>
         </p:nvSpPr>
@@ -16080,7 +15552,7 @@
       </p:sp>
       <p:sp>
         <p:nvSpPr>
-          <p:cNvPr id="7" name="TextBox 6"/>
+          <p:cNvPr id="6" name="TextBox 5"/>
           <p:cNvSpPr txBox="1"/>
           <p:nvPr/>
         </p:nvSpPr>
@@ -16128,7 +15600,7 @@
       </p:sp>
       <p:sp>
         <p:nvSpPr>
-          <p:cNvPr id="8" name="TextBox 7"/>
+          <p:cNvPr id="7" name="TextBox 6"/>
           <p:cNvSpPr txBox="1"/>
           <p:nvPr/>
         </p:nvSpPr>
@@ -16176,13 +15648,13 @@
       </p:sp>
       <p:sp>
         <p:nvSpPr>
-          <p:cNvPr id="9" name="TextBox 8"/>
+          <p:cNvPr id="8" name="TextBox 7"/>
           <p:cNvSpPr txBox="1"/>
           <p:nvPr/>
         </p:nvSpPr>
         <p:spPr>
           <a:xfrm>
-            <a:off x="548640" y="2011680"/>
+            <a:off x="548640" y="1965960"/>
             <a:ext cx="7498079" cy="4572000"/>
           </a:xfrm>
           <a:prstGeom prst="rect">
@@ -16203,7 +15675,7 @@
               <a:spcAft>
                 <a:spcPts val="800"/>
               </a:spcAft>
-              <a:defRPr sz="1600" b="0">
+              <a:defRPr sz="1500" b="0">
                 <a:solidFill>
                   <a:srgbClr val="E2E8F0"/>
                 </a:solidFill>
@@ -16226,16 +15698,52 @@
                 </a:solidFill>
                 <a:latin typeface="Helvetica Neue"/>
               </a:rPr>
-              <a:t>medida con su timestamp</a:t>
-            </a:r>
-            <a:r>
-              <a:rPr>
-                <a:solidFill>
-                  <a:srgbClr val="E2E8F0"/>
-                </a:solidFill>
-                <a:latin typeface="Helvetica Neue"/>
-              </a:rPr>
-              <a:t>: solo se añade, casi nunca se actualiza, y el histórico no cambia.</a:t>
+              <a:t>extensión de PostgreSQL</a:t>
+            </a:r>
+            <a:r>
+              <a:rPr>
+                <a:solidFill>
+                  <a:srgbClr val="E2E8F0"/>
+                </a:solidFill>
+                <a:latin typeface="Helvetica Neue"/>
+              </a:rPr>
+              <a:t> (</a:t>
+            </a:r>
+            <a:r>
+              <a:rPr sz="1500" b="1">
+                <a:solidFill>
+                  <a:srgbClr val="7DD3FC"/>
+                </a:solidFill>
+                <a:latin typeface="Helvetica Neue"/>
+              </a:rPr>
+              <a:t>CREATE EXTENSION timescaledb;</a:t>
+            </a:r>
+            <a:r>
+              <a:rPr>
+                <a:solidFill>
+                  <a:srgbClr val="E2E8F0"/>
+                </a:solidFill>
+                <a:latin typeface="Helvetica Neue"/>
+              </a:rPr>
+              <a:t>), no un motor aparte: SQL, </a:t>
+            </a:r>
+            <a:r>
+              <a:rPr sz="1500" b="1">
+                <a:solidFill>
+                  <a:srgbClr val="7DD3FC"/>
+                </a:solidFill>
+                <a:latin typeface="Helvetica Neue"/>
+              </a:rPr>
+              <a:t>EXPLAIN</a:t>
+            </a:r>
+            <a:r>
+              <a:rPr>
+                <a:solidFill>
+                  <a:srgbClr val="E2E8F0"/>
+                </a:solidFill>
+                <a:latin typeface="Helvetica Neue"/>
+              </a:rPr>
+              <a:t> y catálogo son los de siempre.</a:t>
             </a:r>
           </a:p>
           <a:p>
@@ -16246,21 +15754,21 @@
               <a:spcAft>
                 <a:spcPts val="800"/>
               </a:spcAft>
-              <a:defRPr sz="1600" b="0">
-                <a:solidFill>
-                  <a:srgbClr val="E2E8F0"/>
-                </a:solidFill>
-                <a:latin typeface="Helvetica Neue"/>
-              </a:defRPr>
-            </a:pPr>
-            <a:r>
-              <a:rPr>
-                <a:solidFill>
-                  <a:srgbClr val="E2E8F0"/>
-                </a:solidFill>
-                <a:latin typeface="Helvetica Neue"/>
-              </a:rPr>
-              <a:t>Las preguntas siempre son por </a:t>
+              <a:defRPr sz="1500" b="0">
+                <a:solidFill>
+                  <a:srgbClr val="E2E8F0"/>
+                </a:solidFill>
+                <a:latin typeface="Helvetica Neue"/>
+              </a:defRPr>
+            </a:pPr>
+            <a:r>
+              <a:rPr>
+                <a:solidFill>
+                  <a:srgbClr val="E2E8F0"/>
+                </a:solidFill>
+                <a:latin typeface="Helvetica Neue"/>
+              </a:rPr>
+              <a:t>Cubre la necesidad que nos trae aquí: </a:t>
             </a:r>
             <a:r>
               <a:rPr b="1">
@@ -16269,66 +15777,41 @@
                 </a:solidFill>
                 <a:latin typeface="Helvetica Neue"/>
               </a:rPr>
-              <a:t>ventanas</a:t>
-            </a:r>
-            <a:r>
-              <a:rPr>
-                <a:solidFill>
-                  <a:srgbClr val="E2E8F0"/>
-                </a:solidFill>
-                <a:latin typeface="Helvetica Neue"/>
-              </a:rPr>
-              <a:t>: ¿cuánto y cómo en la última hora, día o mes?</a:t>
-            </a:r>
-          </a:p>
-          <a:p>
-            <a:pPr algn="l">
-              <a:spcBef>
-                <a:spcPts val="0"/>
-              </a:spcBef>
-              <a:spcAft>
-                <a:spcPts val="800"/>
-              </a:spcAft>
-              <a:defRPr sz="1600" b="0">
-                <a:solidFill>
-                  <a:srgbClr val="E2E8F0"/>
-                </a:solidFill>
-                <a:latin typeface="Helvetica Neue"/>
-              </a:defRPr>
-            </a:pPr>
-            <a:r>
-              <a:rPr>
-                <a:solidFill>
-                  <a:srgbClr val="E2E8F0"/>
-                </a:solidFill>
-                <a:latin typeface="Helvetica Neue"/>
-              </a:rPr>
-              <a:t>Crece sin fin: lo que hoy son miles de filas, mañana son millones.</a:t>
-            </a:r>
-          </a:p>
-          <a:p>
-            <a:pPr algn="l">
-              <a:spcBef>
-                <a:spcPts val="0"/>
-              </a:spcBef>
-              <a:spcAft>
-                <a:spcPts val="800"/>
-              </a:spcAft>
-              <a:defRPr sz="1600" b="0">
-                <a:solidFill>
-                  <a:srgbClr val="E2E8F0"/>
-                </a:solidFill>
-                <a:latin typeface="Helvetica Neue"/>
-              </a:defRPr>
-            </a:pPr>
-            <a:r>
-              <a:rPr>
-                <a:solidFill>
-                  <a:srgbClr val="E2E8F0"/>
-                </a:solidFill>
-                <a:latin typeface="Helvetica Neue"/>
-              </a:rPr>
-              <a:t>Nuestra demo: </a:t>
+              <a:t>lecturas que llegan sin parar</a:t>
+            </a:r>
+            <a:r>
+              <a:rPr>
+                <a:solidFill>
+                  <a:srgbClr val="E2E8F0"/>
+                </a:solidFill>
+                <a:latin typeface="Helvetica Neue"/>
+              </a:rPr>
+              <a:t> — IoT, telemetría de flota, métricas, datos financieros — que hay que guardar, consultar por ventanas de tiempo y ordenar su ciclo de vida.</a:t>
+            </a:r>
+          </a:p>
+          <a:p>
+            <a:pPr algn="l">
+              <a:spcBef>
+                <a:spcPts val="0"/>
+              </a:spcBef>
+              <a:spcAft>
+                <a:spcPts val="0"/>
+              </a:spcAft>
+              <a:defRPr sz="1500" b="0">
+                <a:solidFill>
+                  <a:srgbClr val="E2E8F0"/>
+                </a:solidFill>
+                <a:latin typeface="Helvetica Neue"/>
+              </a:defRPr>
+            </a:pPr>
+            <a:r>
+              <a:rPr>
+                <a:solidFill>
+                  <a:srgbClr val="E2E8F0"/>
+                </a:solidFill>
+                <a:latin typeface="Helvetica Neue"/>
+              </a:rPr>
+              <a:t>Y lo hace </a:t>
             </a:r>
             <a:r>
               <a:rPr b="1">
@@ -16337,30 +15820,30 @@
                 </a:solidFill>
                 <a:latin typeface="Helvetica Neue"/>
               </a:rPr>
-              <a:t>10 coches × 24 lecturas/hora × N días × 10 sensores</a:t>
-            </a:r>
-            <a:r>
-              <a:rPr>
-                <a:solidFill>
-                  <a:srgbClr val="E2E8F0"/>
-                </a:solidFill>
-                <a:latin typeface="Helvetica Neue"/>
-              </a:rPr>
-              <a:t> (velocidad, rpm, temperaturas, presiones, autonomía…).</a:t>
-            </a:r>
-          </a:p>
-        </p:txBody>
-      </p:sp>
-      <p:sp>
-        <p:nvSpPr>
-          <p:cNvPr id="10" name="Rounded Rectangle 9"/>
+              <a:t>sin cambiar de base de datos</a:t>
+            </a:r>
+            <a:r>
+              <a:rPr>
+                <a:solidFill>
+                  <a:srgbClr val="E2E8F0"/>
+                </a:solidFill>
+                <a:latin typeface="Helvetica Neue"/>
+              </a:rPr>
+              <a:t>: si ya usas PostgreSQL, lo añades y ya.</a:t>
+            </a:r>
+          </a:p>
+        </p:txBody>
+      </p:sp>
+      <p:sp>
+        <p:nvSpPr>
+          <p:cNvPr id="9" name="Rounded Rectangle 8"/>
           <p:cNvSpPr/>
           <p:nvPr/>
         </p:nvSpPr>
         <p:spPr>
           <a:xfrm>
-            <a:off x="8046720" y="2011680"/>
-            <a:ext cx="3657600" cy="2834640"/>
+            <a:off x="8046720" y="1965960"/>
+            <a:ext cx="3611880" cy="3108960"/>
           </a:xfrm>
           <a:prstGeom prst="roundRect">
             <a:avLst>
@@ -16399,14 +15882,14 @@
       </p:sp>
       <p:sp>
         <p:nvSpPr>
-          <p:cNvPr id="11" name="TextBox 10"/>
+          <p:cNvPr id="10" name="TextBox 9"/>
           <p:cNvSpPr txBox="1"/>
           <p:nvPr/>
         </p:nvSpPr>
         <p:spPr>
           <a:xfrm>
-            <a:off x="8275320" y="2286000"/>
-            <a:ext cx="3200400" cy="2377440"/>
+            <a:off x="8275320" y="2194560"/>
+            <a:ext cx="3154680" cy="2743200"/>
           </a:xfrm>
           <a:prstGeom prst="rect">
             <a:avLst/>
@@ -16440,32 +15923,107 @@
                 </a:solidFill>
                 <a:latin typeface="Helvetica Neue"/>
               </a:rPr>
-              <a:t>En números</a:t>
-            </a:r>
-          </a:p>
-          <a:p>
-            <a:pPr algn="l">
-              <a:spcBef>
-                <a:spcPts val="0"/>
-              </a:spcBef>
-              <a:spcAft>
-                <a:spcPts val="0"/>
-              </a:spcAft>
-              <a:defRPr sz="2600" b="1">
-                <a:solidFill>
-                  <a:srgbClr val="4ADE80"/>
-                </a:solidFill>
-                <a:latin typeface="Helvetica Neue"/>
-              </a:defRPr>
-            </a:pPr>
-            <a:r>
-              <a:rPr>
-                <a:solidFill>
-                  <a:srgbClr val="4ADE80"/>
-                </a:solidFill>
-                <a:latin typeface="Helvetica Neue"/>
-              </a:rPr>
-              <a:t>360 001</a:t>
+              <a:t>Lo que aporta</a:t>
+            </a:r>
+          </a:p>
+          <a:p>
+            <a:pPr algn="l">
+              <a:spcBef>
+                <a:spcPts val="0"/>
+              </a:spcBef>
+              <a:spcAft>
+                <a:spcPts val="400"/>
+              </a:spcAft>
+              <a:defRPr sz="1200" b="0">
+                <a:solidFill>
+                  <a:srgbClr val="E2E8F0"/>
+                </a:solidFill>
+                <a:latin typeface="Helvetica Neue"/>
+              </a:defRPr>
+            </a:pPr>
+            <a:r>
+              <a:rPr>
+                <a:solidFill>
+                  <a:srgbClr val="E2E8F0"/>
+                </a:solidFill>
+                <a:latin typeface="Helvetica Neue"/>
+              </a:rPr>
+              <a:t>· Hipertables: una tabla lógica, particiones por tiempo por dentro</a:t>
+            </a:r>
+          </a:p>
+          <a:p>
+            <a:pPr algn="l">
+              <a:spcBef>
+                <a:spcPts val="0"/>
+              </a:spcBef>
+              <a:spcAft>
+                <a:spcPts val="400"/>
+              </a:spcAft>
+              <a:defRPr sz="1200" b="0">
+                <a:solidFill>
+                  <a:srgbClr val="E2E8F0"/>
+                </a:solidFill>
+                <a:latin typeface="Helvetica Neue"/>
+              </a:defRPr>
+            </a:pPr>
+            <a:r>
+              <a:rPr>
+                <a:solidFill>
+                  <a:srgbClr val="E2E8F0"/>
+                </a:solidFill>
+                <a:latin typeface="Helvetica Neue"/>
+              </a:rPr>
+              <a:t>· Compresión nativa de los bloques viejos</a:t>
+            </a:r>
+          </a:p>
+          <a:p>
+            <a:pPr algn="l">
+              <a:spcBef>
+                <a:spcPts val="0"/>
+              </a:spcBef>
+              <a:spcAft>
+                <a:spcPts val="400"/>
+              </a:spcAft>
+              <a:defRPr sz="1200" b="0">
+                <a:solidFill>
+                  <a:srgbClr val="E2E8F0"/>
+                </a:solidFill>
+                <a:latin typeface="Helvetica Neue"/>
+              </a:defRPr>
+            </a:pPr>
+            <a:r>
+              <a:rPr>
+                <a:solidFill>
+                  <a:srgbClr val="E2E8F0"/>
+                </a:solidFill>
+                <a:latin typeface="Helvetica Neue"/>
+              </a:rPr>
+              <a:t>· Agregados continuos precalculados</a:t>
+            </a:r>
+          </a:p>
+          <a:p>
+            <a:pPr algn="l">
+              <a:spcBef>
+                <a:spcPts val="0"/>
+              </a:spcBef>
+              <a:spcAft>
+                <a:spcPts val="400"/>
+              </a:spcAft>
+              <a:defRPr sz="1200" b="0">
+                <a:solidFill>
+                  <a:srgbClr val="E2E8F0"/>
+                </a:solidFill>
+                <a:latin typeface="Helvetica Neue"/>
+              </a:defRPr>
+            </a:pPr>
+            <a:r>
+              <a:rPr>
+                <a:solidFill>
+                  <a:srgbClr val="E2E8F0"/>
+                </a:solidFill>
+                <a:latin typeface="Helvetica Neue"/>
+              </a:rPr>
+              <a:t>· Retención y autopurga del histórico</a:t>
             </a:r>
           </a:p>
           <a:p>
@@ -16476,7 +16034,32 @@
               <a:spcAft>
                 <a:spcPts val="800"/>
               </a:spcAft>
-              <a:defRPr sz="1100" b="0">
+              <a:defRPr sz="1200" b="0">
+                <a:solidFill>
+                  <a:srgbClr val="E2E8F0"/>
+                </a:solidFill>
+                <a:latin typeface="Helvetica Neue"/>
+              </a:defRPr>
+            </a:pPr>
+            <a:r>
+              <a:rPr>
+                <a:solidFill>
+                  <a:srgbClr val="E2E8F0"/>
+                </a:solidFill>
+                <a:latin typeface="Helvetica Neue"/>
+              </a:rPr>
+              <a:t>· Jobs de fondo con cualquier SQL</a:t>
+            </a:r>
+          </a:p>
+          <a:p>
+            <a:pPr algn="l">
+              <a:spcBef>
+                <a:spcPts val="0"/>
+              </a:spcBef>
+              <a:spcAft>
+                <a:spcPts val="0"/>
+              </a:spcAft>
+              <a:defRPr sz="1200" b="0" i="1">
                 <a:solidFill>
                   <a:srgbClr val="94A3B8"/>
                 </a:solidFill>
@@ -16490,71 +16073,21 @@
                 </a:solidFill>
                 <a:latin typeface="Helvetica Neue"/>
               </a:rPr>
-              <a:t>lecturas por tabla · 4 años</a:t>
-            </a:r>
-          </a:p>
-          <a:p>
-            <a:pPr algn="l">
-              <a:spcBef>
-                <a:spcPts val="0"/>
-              </a:spcBef>
-              <a:spcAft>
-                <a:spcPts val="0"/>
-              </a:spcAft>
-              <a:defRPr sz="2600" b="1">
-                <a:solidFill>
-                  <a:srgbClr val="4ADE80"/>
-                </a:solidFill>
-                <a:latin typeface="Helvetica Neue"/>
-              </a:defRPr>
-            </a:pPr>
-            <a:r>
-              <a:rPr>
-                <a:solidFill>
-                  <a:srgbClr val="4ADE80"/>
-                </a:solidFill>
-                <a:latin typeface="Helvetica Neue"/>
-              </a:rPr>
-              <a:t>1 555 200</a:t>
-            </a:r>
-          </a:p>
-          <a:p>
-            <a:pPr algn="l">
-              <a:spcBef>
-                <a:spcPts val="0"/>
-              </a:spcBef>
-              <a:spcAft>
-                <a:spcPts val="0"/>
-              </a:spcAft>
-              <a:defRPr sz="1100" b="0">
-                <a:solidFill>
-                  <a:srgbClr val="94A3B8"/>
-                </a:solidFill>
-                <a:latin typeface="Helvetica Neue"/>
-              </a:defRPr>
-            </a:pPr>
-            <a:r>
-              <a:rPr>
-                <a:solidFill>
-                  <a:srgbClr val="94A3B8"/>
-                </a:solidFill>
-                <a:latin typeface="Helvetica Neue"/>
-              </a:rPr>
-              <a:t>lecturas de flota cada lectura / 5 s · 9 días</a:t>
-            </a:r>
-          </a:p>
-        </p:txBody>
-      </p:sp>
-      <p:sp>
-        <p:nvSpPr>
-          <p:cNvPr id="12" name="TextBox 11"/>
+              <a:t>Y por debajo, el PostgreSQL que ya conoces.</a:t>
+            </a:r>
+          </a:p>
+        </p:txBody>
+      </p:sp>
+      <p:sp>
+        <p:nvSpPr>
+          <p:cNvPr id="11" name="TextBox 10"/>
           <p:cNvSpPr txBox="1"/>
           <p:nvPr/>
         </p:nvSpPr>
         <p:spPr>
           <a:xfrm>
-            <a:off x="548640" y="5852160"/>
-            <a:ext cx="10972800" cy="365760"/>
+            <a:off x="548640" y="5669280"/>
+            <a:ext cx="11064240" cy="457200"/>
           </a:xfrm>
           <a:prstGeom prst="rect">
             <a:avLst/>
@@ -16574,21 +16107,21 @@
               <a:spcAft>
                 <a:spcPts val="0"/>
               </a:spcAft>
-              <a:defRPr sz="1400" b="1">
-                <a:solidFill>
-                  <a:srgbClr val="FBBF24"/>
-                </a:solidFill>
-                <a:latin typeface="Helvetica Neue"/>
-              </a:defRPr>
-            </a:pPr>
-            <a:r>
-              <a:rPr>
-                <a:solidFill>
-                  <a:srgbClr val="FBBF24"/>
-                </a:solidFill>
-                <a:latin typeface="Helvetica Neue"/>
-              </a:rPr>
-              <a:t>Construido sin borrar la historia: ese es el campo de juego de TimescaleDB.</a:t>
+              <a:defRPr sz="1300" b="0" i="1">
+                <a:solidFill>
+                  <a:srgbClr val="94A3B8"/>
+                </a:solidFill>
+                <a:latin typeface="Helvetica Neue"/>
+              </a:defRPr>
+            </a:pPr>
+            <a:r>
+              <a:rPr>
+                <a:solidFill>
+                  <a:srgbClr val="94A3B8"/>
+                </a:solidFill>
+                <a:latin typeface="Helvetica Neue"/>
+              </a:rPr>
+              <a:t>Mismo SQL, mismo EXPLAIN, mismo catálogo: la diferencia es lo que el motor hace con las tablas por dentro.</a:t>
             </a:r>
           </a:p>
         </p:txBody>
@@ -16663,8 +16196,8 @@
         </p:nvSpPr>
         <p:spPr>
           <a:xfrm>
-            <a:off x="548640" y="411479"/>
-            <a:ext cx="8229600" cy="320040"/>
+            <a:off x="548640" y="457200"/>
+            <a:ext cx="11064240" cy="548640"/>
           </a:xfrm>
           <a:prstGeom prst="rect">
             <a:avLst/>
@@ -16684,54 +16217,6 @@
               <a:spcAft>
                 <a:spcPts val="0"/>
               </a:spcAft>
-              <a:defRPr sz="1300" b="1">
-                <a:solidFill>
-                  <a:srgbClr val="FBBF24"/>
-                </a:solidFill>
-                <a:latin typeface="Helvetica Neue"/>
-              </a:defRPr>
-            </a:pPr>
-            <a:r>
-              <a:rPr>
-                <a:solidFill>
-                  <a:srgbClr val="FBBF24"/>
-                </a:solidFill>
-                <a:latin typeface="Helvetica Neue"/>
-              </a:rPr>
-              <a:t>APARTADO 01 · MODELO DE DATOS</a:t>
-            </a:r>
-          </a:p>
-        </p:txBody>
-      </p:sp>
-      <p:sp>
-        <p:nvSpPr>
-          <p:cNvPr id="4" name="TextBox 3"/>
-          <p:cNvSpPr txBox="1"/>
-          <p:nvPr/>
-        </p:nvSpPr>
-        <p:spPr>
-          <a:xfrm>
-            <a:off x="548640" y="676656"/>
-            <a:ext cx="11064240" cy="548640"/>
-          </a:xfrm>
-          <a:prstGeom prst="rect">
-            <a:avLst/>
-          </a:prstGeom>
-          <a:noFill/>
-        </p:spPr>
-        <p:txBody>
-          <a:bodyPr wrap="square" anchor="t" lIns="0" rIns="0" tIns="0" bIns="0">
-            <a:spAutoFit/>
-          </a:bodyPr>
-          <a:lstStyle/>
-          <a:p>
-            <a:pPr algn="l">
-              <a:spcBef>
-                <a:spcPts val="0"/>
-              </a:spcBef>
-              <a:spcAft>
-                <a:spcPts val="0"/>
-              </a:spcAft>
               <a:defRPr sz="3000" b="1">
                 <a:solidFill>
                   <a:srgbClr val="E2E8F0"/>
@@ -16753,13 +16238,13 @@
       </p:sp>
       <p:sp>
         <p:nvSpPr>
-          <p:cNvPr id="5" name="Rectangle 4"/>
+          <p:cNvPr id="4" name="Rectangle 3"/>
           <p:cNvSpPr/>
           <p:nvPr/>
         </p:nvSpPr>
         <p:spPr>
           <a:xfrm>
-            <a:off x="548640" y="1033271"/>
+            <a:off x="548640" y="813816"/>
             <a:ext cx="960120" cy="41148"/>
           </a:xfrm>
           <a:prstGeom prst="rect">
@@ -16797,7 +16282,7 @@
       </p:sp>
       <p:sp>
         <p:nvSpPr>
-          <p:cNvPr id="6" name="Rectangle 5"/>
+          <p:cNvPr id="5" name="Rectangle 4"/>
           <p:cNvSpPr/>
           <p:nvPr/>
         </p:nvSpPr>
@@ -16841,7 +16326,7 @@
       </p:sp>
       <p:sp>
         <p:nvSpPr>
-          <p:cNvPr id="7" name="TextBox 6"/>
+          <p:cNvPr id="6" name="TextBox 5"/>
           <p:cNvSpPr txBox="1"/>
           <p:nvPr/>
         </p:nvSpPr>
@@ -16889,7 +16374,7 @@
       </p:sp>
       <p:sp>
         <p:nvSpPr>
-          <p:cNvPr id="8" name="TextBox 7"/>
+          <p:cNvPr id="7" name="TextBox 6"/>
           <p:cNvSpPr txBox="1"/>
           <p:nvPr/>
         </p:nvSpPr>
@@ -16937,7 +16422,7 @@
       </p:sp>
       <p:sp>
         <p:nvSpPr>
-          <p:cNvPr id="9" name="TextBox 8"/>
+          <p:cNvPr id="8" name="TextBox 7"/>
           <p:cNvSpPr txBox="1"/>
           <p:nvPr/>
         </p:nvSpPr>
@@ -17143,7 +16628,7 @@
       </p:sp>
       <p:sp>
         <p:nvSpPr>
-          <p:cNvPr id="10" name="Rounded Rectangle 9"/>
+          <p:cNvPr id="9" name="Rounded Rectangle 8"/>
           <p:cNvSpPr/>
           <p:nvPr/>
         </p:nvSpPr>
@@ -17189,7 +16674,7 @@
       </p:sp>
       <p:sp>
         <p:nvSpPr>
-          <p:cNvPr id="11" name="TextBox 10"/>
+          <p:cNvPr id="10" name="TextBox 9"/>
           <p:cNvSpPr txBox="1"/>
           <p:nvPr/>
         </p:nvSpPr>
@@ -17328,7 +16813,7 @@
       </p:sp>
       <p:sp>
         <p:nvSpPr>
-          <p:cNvPr id="12" name="Rounded Rectangle 11"/>
+          <p:cNvPr id="11" name="Rounded Rectangle 10"/>
           <p:cNvSpPr/>
           <p:nvPr/>
         </p:nvSpPr>
@@ -17374,7 +16859,7 @@
       </p:sp>
       <p:sp>
         <p:nvSpPr>
-          <p:cNvPr id="13" name="TextBox 12"/>
+          <p:cNvPr id="12" name="TextBox 11"/>
           <p:cNvSpPr txBox="1"/>
           <p:nvPr/>
         </p:nvSpPr>
@@ -17610,8 +17095,8 @@
         </p:nvSpPr>
         <p:spPr>
           <a:xfrm>
-            <a:off x="548640" y="411479"/>
-            <a:ext cx="8229600" cy="320040"/>
+            <a:off x="548640" y="457200"/>
+            <a:ext cx="11064240" cy="548640"/>
           </a:xfrm>
           <a:prstGeom prst="rect">
             <a:avLst/>
@@ -17631,54 +17116,6 @@
               <a:spcAft>
                 <a:spcPts val="0"/>
               </a:spcAft>
-              <a:defRPr sz="1300" b="1">
-                <a:solidFill>
-                  <a:srgbClr val="FBBF24"/>
-                </a:solidFill>
-                <a:latin typeface="Helvetica Neue"/>
-              </a:defRPr>
-            </a:pPr>
-            <a:r>
-              <a:rPr>
-                <a:solidFill>
-                  <a:srgbClr val="FBBF24"/>
-                </a:solidFill>
-                <a:latin typeface="Helvetica Neue"/>
-              </a:rPr>
-              <a:t>APARTADO 02 · CONFIGURACIÓN</a:t>
-            </a:r>
-          </a:p>
-        </p:txBody>
-      </p:sp>
-      <p:sp>
-        <p:nvSpPr>
-          <p:cNvPr id="4" name="TextBox 3"/>
-          <p:cNvSpPr txBox="1"/>
-          <p:nvPr/>
-        </p:nvSpPr>
-        <p:spPr>
-          <a:xfrm>
-            <a:off x="548640" y="676656"/>
-            <a:ext cx="11064240" cy="548640"/>
-          </a:xfrm>
-          <a:prstGeom prst="rect">
-            <a:avLst/>
-          </a:prstGeom>
-          <a:noFill/>
-        </p:spPr>
-        <p:txBody>
-          <a:bodyPr wrap="square" anchor="t" lIns="0" rIns="0" tIns="0" bIns="0">
-            <a:spAutoFit/>
-          </a:bodyPr>
-          <a:lstStyle/>
-          <a:p>
-            <a:pPr algn="l">
-              <a:spcBef>
-                <a:spcPts val="0"/>
-              </a:spcBef>
-              <a:spcAft>
-                <a:spcPts val="0"/>
-              </a:spcAft>
               <a:defRPr sz="3000" b="1">
                 <a:solidFill>
                   <a:srgbClr val="E2E8F0"/>
@@ -17700,13 +17137,13 @@
       </p:sp>
       <p:sp>
         <p:nvSpPr>
-          <p:cNvPr id="5" name="Rectangle 4"/>
+          <p:cNvPr id="4" name="Rectangle 3"/>
           <p:cNvSpPr/>
           <p:nvPr/>
         </p:nvSpPr>
         <p:spPr>
           <a:xfrm>
-            <a:off x="548640" y="1033271"/>
+            <a:off x="548640" y="813816"/>
             <a:ext cx="960120" cy="41148"/>
           </a:xfrm>
           <a:prstGeom prst="rect">
@@ -17744,7 +17181,7 @@
       </p:sp>
       <p:sp>
         <p:nvSpPr>
-          <p:cNvPr id="6" name="Rectangle 5"/>
+          <p:cNvPr id="5" name="Rectangle 4"/>
           <p:cNvSpPr/>
           <p:nvPr/>
         </p:nvSpPr>
@@ -17788,7 +17225,7 @@
       </p:sp>
       <p:sp>
         <p:nvSpPr>
-          <p:cNvPr id="7" name="TextBox 6"/>
+          <p:cNvPr id="6" name="TextBox 5"/>
           <p:cNvSpPr txBox="1"/>
           <p:nvPr/>
         </p:nvSpPr>
@@ -17836,7 +17273,7 @@
       </p:sp>
       <p:sp>
         <p:nvSpPr>
-          <p:cNvPr id="8" name="TextBox 7"/>
+          <p:cNvPr id="7" name="TextBox 6"/>
           <p:cNvSpPr txBox="1"/>
           <p:nvPr/>
         </p:nvSpPr>
@@ -17884,7 +17321,7 @@
       </p:sp>
       <p:sp>
         <p:nvSpPr>
-          <p:cNvPr id="9" name="TextBox 8"/>
+          <p:cNvPr id="8" name="TextBox 7"/>
           <p:cNvSpPr txBox="1"/>
           <p:nvPr/>
         </p:nvSpPr>
@@ -18036,7 +17473,7 @@
       </p:sp>
       <p:sp>
         <p:nvSpPr>
-          <p:cNvPr id="10" name="Rounded Rectangle 9"/>
+          <p:cNvPr id="9" name="Rounded Rectangle 8"/>
           <p:cNvSpPr/>
           <p:nvPr/>
         </p:nvSpPr>
@@ -18082,7 +17519,7 @@
       </p:sp>
       <p:sp>
         <p:nvSpPr>
-          <p:cNvPr id="11" name="TextBox 10"/>
+          <p:cNvPr id="10" name="TextBox 9"/>
           <p:cNvSpPr txBox="1"/>
           <p:nvPr/>
         </p:nvSpPr>
@@ -18248,8 +17685,8 @@
         </p:nvSpPr>
         <p:spPr>
           <a:xfrm>
-            <a:off x="548640" y="411479"/>
-            <a:ext cx="8229600" cy="320040"/>
+            <a:off x="548640" y="457200"/>
+            <a:ext cx="11064240" cy="548640"/>
           </a:xfrm>
           <a:prstGeom prst="rect">
             <a:avLst/>
@@ -18269,54 +17706,6 @@
               <a:spcAft>
                 <a:spcPts val="0"/>
               </a:spcAft>
-              <a:defRPr sz="1300" b="1">
-                <a:solidFill>
-                  <a:srgbClr val="FBBF24"/>
-                </a:solidFill>
-                <a:latin typeface="Helvetica Neue"/>
-              </a:defRPr>
-            </a:pPr>
-            <a:r>
-              <a:rPr>
-                <a:solidFill>
-                  <a:srgbClr val="FBBF24"/>
-                </a:solidFill>
-                <a:latin typeface="Helvetica Neue"/>
-              </a:rPr>
-              <a:t>APARTADO 03 · CÓMO GUARDAMOS</a:t>
-            </a:r>
-          </a:p>
-        </p:txBody>
-      </p:sp>
-      <p:sp>
-        <p:nvSpPr>
-          <p:cNvPr id="4" name="TextBox 3"/>
-          <p:cNvSpPr txBox="1"/>
-          <p:nvPr/>
-        </p:nvSpPr>
-        <p:spPr>
-          <a:xfrm>
-            <a:off x="548640" y="676656"/>
-            <a:ext cx="11064240" cy="548640"/>
-          </a:xfrm>
-          <a:prstGeom prst="rect">
-            <a:avLst/>
-          </a:prstGeom>
-          <a:noFill/>
-        </p:spPr>
-        <p:txBody>
-          <a:bodyPr wrap="square" anchor="t" lIns="0" rIns="0" tIns="0" bIns="0">
-            <a:spAutoFit/>
-          </a:bodyPr>
-          <a:lstStyle/>
-          <a:p>
-            <a:pPr algn="l">
-              <a:spcBef>
-                <a:spcPts val="0"/>
-              </a:spcBef>
-              <a:spcAft>
-                <a:spcPts val="0"/>
-              </a:spcAft>
               <a:defRPr sz="3000" b="1">
                 <a:solidFill>
                   <a:srgbClr val="E2E8F0"/>
@@ -18338,13 +17727,13 @@
       </p:sp>
       <p:sp>
         <p:nvSpPr>
-          <p:cNvPr id="5" name="Rectangle 4"/>
+          <p:cNvPr id="4" name="Rectangle 3"/>
           <p:cNvSpPr/>
           <p:nvPr/>
         </p:nvSpPr>
         <p:spPr>
           <a:xfrm>
-            <a:off x="548640" y="1033271"/>
+            <a:off x="548640" y="813816"/>
             <a:ext cx="960120" cy="41148"/>
           </a:xfrm>
           <a:prstGeom prst="rect">
@@ -18382,7 +17771,7 @@
       </p:sp>
       <p:sp>
         <p:nvSpPr>
-          <p:cNvPr id="6" name="Rectangle 5"/>
+          <p:cNvPr id="5" name="Rectangle 4"/>
           <p:cNvSpPr/>
           <p:nvPr/>
         </p:nvSpPr>
@@ -18426,7 +17815,7 @@
       </p:sp>
       <p:sp>
         <p:nvSpPr>
-          <p:cNvPr id="7" name="TextBox 6"/>
+          <p:cNvPr id="6" name="TextBox 5"/>
           <p:cNvSpPr txBox="1"/>
           <p:nvPr/>
         </p:nvSpPr>
@@ -18474,7 +17863,7 @@
       </p:sp>
       <p:sp>
         <p:nvSpPr>
-          <p:cNvPr id="8" name="TextBox 7"/>
+          <p:cNvPr id="7" name="TextBox 6"/>
           <p:cNvSpPr txBox="1"/>
           <p:nvPr/>
         </p:nvSpPr>
@@ -18522,7 +17911,7 @@
       </p:sp>
       <p:sp>
         <p:nvSpPr>
-          <p:cNvPr id="9" name="TextBox 8"/>
+          <p:cNvPr id="8" name="TextBox 7"/>
           <p:cNvSpPr txBox="1"/>
           <p:nvPr/>
         </p:nvSpPr>
@@ -18873,7 +18262,7 @@
       </p:sp>
       <p:sp>
         <p:nvSpPr>
-          <p:cNvPr id="10" name="Rounded Rectangle 9"/>
+          <p:cNvPr id="9" name="Rounded Rectangle 8"/>
           <p:cNvSpPr/>
           <p:nvPr/>
         </p:nvSpPr>
@@ -18919,7 +18308,7 @@
       </p:sp>
       <p:sp>
         <p:nvSpPr>
-          <p:cNvPr id="11" name="TextBox 10"/>
+          <p:cNvPr id="10" name="TextBox 9"/>
           <p:cNvSpPr txBox="1"/>
           <p:nvPr/>
         </p:nvSpPr>
@@ -19042,7 +18431,7 @@
       </p:sp>
       <p:sp>
         <p:nvSpPr>
-          <p:cNvPr id="12" name="TextBox 11"/>
+          <p:cNvPr id="11" name="TextBox 10"/>
           <p:cNvSpPr txBox="1"/>
           <p:nvPr/>
         </p:nvSpPr>
@@ -19167,8 +18556,8 @@
         </p:nvSpPr>
         <p:spPr>
           <a:xfrm>
-            <a:off x="548640" y="411479"/>
-            <a:ext cx="8229600" cy="320040"/>
+            <a:off x="548640" y="457200"/>
+            <a:ext cx="11064240" cy="548640"/>
           </a:xfrm>
           <a:prstGeom prst="rect">
             <a:avLst/>
@@ -19188,54 +18577,6 @@
               <a:spcAft>
                 <a:spcPts val="0"/>
               </a:spcAft>
-              <a:defRPr sz="1300" b="1">
-                <a:solidFill>
-                  <a:srgbClr val="FBBF24"/>
-                </a:solidFill>
-                <a:latin typeface="Helvetica Neue"/>
-              </a:defRPr>
-            </a:pPr>
-            <a:r>
-              <a:rPr>
-                <a:solidFill>
-                  <a:srgbClr val="FBBF24"/>
-                </a:solidFill>
-                <a:latin typeface="Helvetica Neue"/>
-              </a:rPr>
-              <a:t>APARTADO 03 · DEMO</a:t>
-            </a:r>
-          </a:p>
-        </p:txBody>
-      </p:sp>
-      <p:sp>
-        <p:nvSpPr>
-          <p:cNvPr id="4" name="TextBox 3"/>
-          <p:cNvSpPr txBox="1"/>
-          <p:nvPr/>
-        </p:nvSpPr>
-        <p:spPr>
-          <a:xfrm>
-            <a:off x="548640" y="676656"/>
-            <a:ext cx="11064240" cy="548640"/>
-          </a:xfrm>
-          <a:prstGeom prst="rect">
-            <a:avLst/>
-          </a:prstGeom>
-          <a:noFill/>
-        </p:spPr>
-        <p:txBody>
-          <a:bodyPr wrap="square" anchor="t" lIns="0" rIns="0" tIns="0" bIns="0">
-            <a:spAutoFit/>
-          </a:bodyPr>
-          <a:lstStyle/>
-          <a:p>
-            <a:pPr algn="l">
-              <a:spcBef>
-                <a:spcPts val="0"/>
-              </a:spcBef>
-              <a:spcAft>
-                <a:spcPts val="0"/>
-              </a:spcAft>
               <a:defRPr sz="3000" b="1">
                 <a:solidFill>
                   <a:srgbClr val="E2E8F0"/>
@@ -19257,13 +18598,13 @@
       </p:sp>
       <p:sp>
         <p:nvSpPr>
-          <p:cNvPr id="5" name="Rectangle 4"/>
+          <p:cNvPr id="4" name="Rectangle 3"/>
           <p:cNvSpPr/>
           <p:nvPr/>
         </p:nvSpPr>
         <p:spPr>
           <a:xfrm>
-            <a:off x="548640" y="1033271"/>
+            <a:off x="548640" y="813816"/>
             <a:ext cx="960120" cy="41148"/>
           </a:xfrm>
           <a:prstGeom prst="rect">
@@ -19301,7 +18642,7 @@
       </p:sp>
       <p:sp>
         <p:nvSpPr>
-          <p:cNvPr id="6" name="Rectangle 5"/>
+          <p:cNvPr id="5" name="Rectangle 4"/>
           <p:cNvSpPr/>
           <p:nvPr/>
         </p:nvSpPr>
@@ -19345,7 +18686,7 @@
       </p:sp>
       <p:sp>
         <p:nvSpPr>
-          <p:cNvPr id="7" name="TextBox 6"/>
+          <p:cNvPr id="6" name="TextBox 5"/>
           <p:cNvSpPr txBox="1"/>
           <p:nvPr/>
         </p:nvSpPr>
@@ -19393,7 +18734,7 @@
       </p:sp>
       <p:sp>
         <p:nvSpPr>
-          <p:cNvPr id="8" name="TextBox 7"/>
+          <p:cNvPr id="7" name="TextBox 6"/>
           <p:cNvSpPr txBox="1"/>
           <p:nvPr/>
         </p:nvSpPr>
@@ -19441,7 +18782,7 @@
       </p:sp>
       <p:sp>
         <p:nvSpPr>
-          <p:cNvPr id="9" name="Rectangle 8"/>
+          <p:cNvPr id="8" name="Rectangle 7"/>
           <p:cNvSpPr/>
           <p:nvPr/>
         </p:nvSpPr>
@@ -19485,7 +18826,7 @@
       </p:sp>
       <p:sp>
         <p:nvSpPr>
-          <p:cNvPr id="10" name="TextBox 9"/>
+          <p:cNvPr id="9" name="TextBox 8"/>
           <p:cNvSpPr txBox="1"/>
           <p:nvPr/>
         </p:nvSpPr>
@@ -19533,7 +18874,7 @@
       </p:sp>
       <p:sp>
         <p:nvSpPr>
-          <p:cNvPr id="11" name="TextBox 10"/>
+          <p:cNvPr id="10" name="TextBox 9"/>
           <p:cNvSpPr txBox="1"/>
           <p:nvPr/>
         </p:nvSpPr>
@@ -19581,7 +18922,7 @@
       </p:sp>
       <p:sp>
         <p:nvSpPr>
-          <p:cNvPr id="12" name="TextBox 11"/>
+          <p:cNvPr id="11" name="TextBox 10"/>
           <p:cNvSpPr txBox="1"/>
           <p:nvPr/>
         </p:nvSpPr>
@@ -19629,7 +18970,7 @@
       </p:sp>
       <p:sp>
         <p:nvSpPr>
-          <p:cNvPr id="13" name="TextBox 12"/>
+          <p:cNvPr id="12" name="TextBox 11"/>
           <p:cNvSpPr txBox="1"/>
           <p:nvPr/>
         </p:nvSpPr>
@@ -19677,7 +19018,7 @@
       </p:sp>
       <p:sp>
         <p:nvSpPr>
-          <p:cNvPr id="14" name="TextBox 13"/>
+          <p:cNvPr id="13" name="TextBox 12"/>
           <p:cNvSpPr txBox="1"/>
           <p:nvPr/>
         </p:nvSpPr>
@@ -19725,7 +19066,7 @@
       </p:sp>
       <p:sp>
         <p:nvSpPr>
-          <p:cNvPr id="15" name="Rectangle 14"/>
+          <p:cNvPr id="14" name="Rectangle 13"/>
           <p:cNvSpPr/>
           <p:nvPr/>
         </p:nvSpPr>
@@ -19769,7 +19110,7 @@
       </p:sp>
       <p:sp>
         <p:nvSpPr>
-          <p:cNvPr id="16" name="TextBox 15"/>
+          <p:cNvPr id="15" name="TextBox 14"/>
           <p:cNvSpPr txBox="1"/>
           <p:nvPr/>
         </p:nvSpPr>
@@ -19817,7 +19158,7 @@
       </p:sp>
       <p:sp>
         <p:nvSpPr>
-          <p:cNvPr id="17" name="TextBox 16"/>
+          <p:cNvPr id="16" name="TextBox 15"/>
           <p:cNvSpPr txBox="1"/>
           <p:nvPr/>
         </p:nvSpPr>
@@ -19865,7 +19206,7 @@
       </p:sp>
       <p:sp>
         <p:nvSpPr>
-          <p:cNvPr id="18" name="TextBox 17"/>
+          <p:cNvPr id="17" name="TextBox 16"/>
           <p:cNvSpPr txBox="1"/>
           <p:nvPr/>
         </p:nvSpPr>
@@ -19913,7 +19254,7 @@
       </p:sp>
       <p:sp>
         <p:nvSpPr>
-          <p:cNvPr id="19" name="TextBox 18"/>
+          <p:cNvPr id="18" name="TextBox 17"/>
           <p:cNvSpPr txBox="1"/>
           <p:nvPr/>
         </p:nvSpPr>
@@ -19961,7 +19302,7 @@
       </p:sp>
       <p:sp>
         <p:nvSpPr>
-          <p:cNvPr id="20" name="TextBox 19"/>
+          <p:cNvPr id="19" name="TextBox 18"/>
           <p:cNvSpPr txBox="1"/>
           <p:nvPr/>
         </p:nvSpPr>
@@ -20009,7 +19350,7 @@
       </p:sp>
       <p:sp>
         <p:nvSpPr>
-          <p:cNvPr id="21" name="Rectangle 20"/>
+          <p:cNvPr id="20" name="Rectangle 19"/>
           <p:cNvSpPr/>
           <p:nvPr/>
         </p:nvSpPr>
@@ -20053,7 +19394,7 @@
       </p:sp>
       <p:sp>
         <p:nvSpPr>
-          <p:cNvPr id="22" name="TextBox 21"/>
+          <p:cNvPr id="21" name="TextBox 20"/>
           <p:cNvSpPr txBox="1"/>
           <p:nvPr/>
         </p:nvSpPr>
@@ -20101,7 +19442,7 @@
       </p:sp>
       <p:sp>
         <p:nvSpPr>
-          <p:cNvPr id="23" name="TextBox 22"/>
+          <p:cNvPr id="22" name="TextBox 21"/>
           <p:cNvSpPr txBox="1"/>
           <p:nvPr/>
         </p:nvSpPr>
@@ -20149,7 +19490,7 @@
       </p:sp>
       <p:sp>
         <p:nvSpPr>
-          <p:cNvPr id="24" name="TextBox 23"/>
+          <p:cNvPr id="23" name="TextBox 22"/>
           <p:cNvSpPr txBox="1"/>
           <p:nvPr/>
         </p:nvSpPr>
@@ -20197,7 +19538,7 @@
       </p:sp>
       <p:sp>
         <p:nvSpPr>
-          <p:cNvPr id="25" name="TextBox 24"/>
+          <p:cNvPr id="24" name="TextBox 23"/>
           <p:cNvSpPr txBox="1"/>
           <p:nvPr/>
         </p:nvSpPr>
@@ -20245,7 +19586,7 @@
       </p:sp>
       <p:sp>
         <p:nvSpPr>
-          <p:cNvPr id="26" name="TextBox 25"/>
+          <p:cNvPr id="25" name="TextBox 24"/>
           <p:cNvSpPr txBox="1"/>
           <p:nvPr/>
         </p:nvSpPr>
@@ -20293,7 +19634,7 @@
       </p:sp>
       <p:sp>
         <p:nvSpPr>
-          <p:cNvPr id="27" name="Rectangle 26"/>
+          <p:cNvPr id="26" name="Rectangle 25"/>
           <p:cNvSpPr/>
           <p:nvPr/>
         </p:nvSpPr>
@@ -20337,7 +19678,7 @@
       </p:sp>
       <p:sp>
         <p:nvSpPr>
-          <p:cNvPr id="28" name="TextBox 27"/>
+          <p:cNvPr id="27" name="TextBox 26"/>
           <p:cNvSpPr txBox="1"/>
           <p:nvPr/>
         </p:nvSpPr>
@@ -20385,7 +19726,7 @@
       </p:sp>
       <p:sp>
         <p:nvSpPr>
-          <p:cNvPr id="29" name="TextBox 28"/>
+          <p:cNvPr id="28" name="TextBox 27"/>
           <p:cNvSpPr txBox="1"/>
           <p:nvPr/>
         </p:nvSpPr>
@@ -20433,7 +19774,7 @@
       </p:sp>
       <p:sp>
         <p:nvSpPr>
-          <p:cNvPr id="30" name="TextBox 29"/>
+          <p:cNvPr id="29" name="TextBox 28"/>
           <p:cNvSpPr txBox="1"/>
           <p:nvPr/>
         </p:nvSpPr>
@@ -20481,7 +19822,7 @@
       </p:sp>
       <p:sp>
         <p:nvSpPr>
-          <p:cNvPr id="31" name="TextBox 30"/>
+          <p:cNvPr id="30" name="TextBox 29"/>
           <p:cNvSpPr txBox="1"/>
           <p:nvPr/>
         </p:nvSpPr>
@@ -20529,7 +19870,7 @@
       </p:sp>
       <p:sp>
         <p:nvSpPr>
-          <p:cNvPr id="32" name="TextBox 31"/>
+          <p:cNvPr id="31" name="TextBox 30"/>
           <p:cNvSpPr txBox="1"/>
           <p:nvPr/>
         </p:nvSpPr>
@@ -20577,7 +19918,7 @@
       </p:sp>
       <p:sp>
         <p:nvSpPr>
-          <p:cNvPr id="33" name="TextBox 32"/>
+          <p:cNvPr id="32" name="TextBox 31"/>
           <p:cNvSpPr txBox="1"/>
           <p:nvPr/>
         </p:nvSpPr>
@@ -20808,7 +20149,7 @@
       </p:sp>
       <p:sp>
         <p:nvSpPr>
-          <p:cNvPr id="34" name="TextBox 33"/>
+          <p:cNvPr id="33" name="TextBox 32"/>
           <p:cNvSpPr txBox="1"/>
           <p:nvPr/>
         </p:nvSpPr>
@@ -20856,7 +20197,7 @@
       </p:sp>
       <p:sp>
         <p:nvSpPr>
-          <p:cNvPr id="35" name="TextBox 34"/>
+          <p:cNvPr id="34" name="TextBox 33"/>
           <p:cNvSpPr txBox="1"/>
           <p:nvPr/>
         </p:nvSpPr>
@@ -20972,8 +20313,8 @@
         </p:nvSpPr>
         <p:spPr>
           <a:xfrm>
-            <a:off x="548640" y="411479"/>
-            <a:ext cx="8229600" cy="320040"/>
+            <a:off x="548640" y="457200"/>
+            <a:ext cx="11064240" cy="548640"/>
           </a:xfrm>
           <a:prstGeom prst="rect">
             <a:avLst/>
@@ -20993,54 +20334,6 @@
               <a:spcAft>
                 <a:spcPts val="0"/>
               </a:spcAft>
-              <a:defRPr sz="1300" b="1">
-                <a:solidFill>
-                  <a:srgbClr val="FBBF24"/>
-                </a:solidFill>
-                <a:latin typeface="Helvetica Neue"/>
-              </a:defRPr>
-            </a:pPr>
-            <a:r>
-              <a:rPr>
-                <a:solidFill>
-                  <a:srgbClr val="FBBF24"/>
-                </a:solidFill>
-                <a:latin typeface="Helvetica Neue"/>
-              </a:rPr>
-              <a:t>APARTADO 04 · COMPORTAMIENTO</a:t>
-            </a:r>
-          </a:p>
-        </p:txBody>
-      </p:sp>
-      <p:sp>
-        <p:nvSpPr>
-          <p:cNvPr id="4" name="TextBox 3"/>
-          <p:cNvSpPr txBox="1"/>
-          <p:nvPr/>
-        </p:nvSpPr>
-        <p:spPr>
-          <a:xfrm>
-            <a:off x="548640" y="676656"/>
-            <a:ext cx="11064240" cy="548640"/>
-          </a:xfrm>
-          <a:prstGeom prst="rect">
-            <a:avLst/>
-          </a:prstGeom>
-          <a:noFill/>
-        </p:spPr>
-        <p:txBody>
-          <a:bodyPr wrap="square" anchor="t" lIns="0" rIns="0" tIns="0" bIns="0">
-            <a:spAutoFit/>
-          </a:bodyPr>
-          <a:lstStyle/>
-          <a:p>
-            <a:pPr algn="l">
-              <a:spcBef>
-                <a:spcPts val="0"/>
-              </a:spcBef>
-              <a:spcAft>
-                <a:spcPts val="0"/>
-              </a:spcAft>
               <a:defRPr sz="3000" b="1">
                 <a:solidFill>
                   <a:srgbClr val="E2E8F0"/>
@@ -21062,13 +20355,13 @@
       </p:sp>
       <p:sp>
         <p:nvSpPr>
-          <p:cNvPr id="5" name="Rectangle 4"/>
+          <p:cNvPr id="4" name="Rectangle 3"/>
           <p:cNvSpPr/>
           <p:nvPr/>
         </p:nvSpPr>
         <p:spPr>
           <a:xfrm>
-            <a:off x="548640" y="1033271"/>
+            <a:off x="548640" y="813816"/>
             <a:ext cx="960120" cy="41148"/>
           </a:xfrm>
           <a:prstGeom prst="rect">
@@ -21106,7 +20399,7 @@
       </p:sp>
       <p:sp>
         <p:nvSpPr>
-          <p:cNvPr id="6" name="Rectangle 5"/>
+          <p:cNvPr id="5" name="Rectangle 4"/>
           <p:cNvSpPr/>
           <p:nvPr/>
         </p:nvSpPr>
@@ -21150,7 +20443,7 @@
       </p:sp>
       <p:sp>
         <p:nvSpPr>
-          <p:cNvPr id="7" name="TextBox 6"/>
+          <p:cNvPr id="6" name="TextBox 5"/>
           <p:cNvSpPr txBox="1"/>
           <p:nvPr/>
         </p:nvSpPr>
@@ -21198,7 +20491,7 @@
       </p:sp>
       <p:sp>
         <p:nvSpPr>
-          <p:cNvPr id="8" name="TextBox 7"/>
+          <p:cNvPr id="7" name="TextBox 6"/>
           <p:cNvSpPr txBox="1"/>
           <p:nvPr/>
         </p:nvSpPr>
@@ -21246,7 +20539,7 @@
       </p:sp>
       <p:sp>
         <p:nvSpPr>
-          <p:cNvPr id="9" name="TextBox 8"/>
+          <p:cNvPr id="8" name="TextBox 7"/>
           <p:cNvSpPr txBox="1"/>
           <p:nvPr/>
         </p:nvSpPr>
@@ -21597,7 +20890,7 @@
       </p:sp>
       <p:sp>
         <p:nvSpPr>
-          <p:cNvPr id="10" name="Rounded Rectangle 9"/>
+          <p:cNvPr id="9" name="Rounded Rectangle 8"/>
           <p:cNvSpPr/>
           <p:nvPr/>
         </p:nvSpPr>
@@ -21643,7 +20936,7 @@
       </p:sp>
       <p:sp>
         <p:nvSpPr>
-          <p:cNvPr id="11" name="TextBox 10"/>
+          <p:cNvPr id="10" name="TextBox 9"/>
           <p:cNvSpPr txBox="1"/>
           <p:nvPr/>
         </p:nvSpPr>
@@ -21741,7 +21034,7 @@
       </p:sp>
       <p:sp>
         <p:nvSpPr>
-          <p:cNvPr id="12" name="TextBox 11"/>
+          <p:cNvPr id="11" name="TextBox 10"/>
           <p:cNvSpPr txBox="1"/>
           <p:nvPr/>
         </p:nvSpPr>

</xml_diff>

<commit_message>
renombrar vehiculos_gorda a vehiculos_grande (tabla, esquema, scripts, README, PPT) + recrear entorno
</commit_message>
<xml_diff>
--- a/presentacion/TimescaleDB-PPT-Javier.pptx
+++ b/presentacion/TimescaleDB-PPT-Javier.pptx
@@ -3903,7 +3903,7 @@
                 </a:solidFill>
                 <a:latin typeface="Helvetica Neue"/>
               </a:rPr>
-              <a:t>SELECT add_compression_policy('vehiculos_gorda',</a:t>
+              <a:t>SELECT add_compression_policy('vehiculos_grande',</a:t>
             </a:r>
           </a:p>
           <a:p>
@@ -4044,7 +4044,7 @@
                 </a:solidFill>
                 <a:latin typeface="Helvetica Neue"/>
               </a:rPr>
-              <a:t>SELECT remove_compression_policy('vehiculos_gorda'); -- borrar</a:t>
+              <a:t>SELECT remove_compression_policy('vehiculos_grande'); -- borrar</a:t>
             </a:r>
           </a:p>
         </p:txBody>
@@ -5623,7 +5623,7 @@
                 </a:solidFill>
                 <a:latin typeface="Helvetica Neue"/>
               </a:rPr>
-              <a:t>vehiculos_gorda (comprimida)</a:t>
+              <a:t>vehiculos_grande (comprimida)</a:t>
             </a:r>
           </a:p>
         </p:txBody>
@@ -6326,7 +6326,7 @@
                 </a:solidFill>
                 <a:latin typeface="Helvetica Neue"/>
               </a:rPr>
-              <a:t>SELECT drop_chunks('vehiculos_gorda', older_than =&gt; now() - INTERVAL '5 days');</a:t>
+              <a:t>SELECT drop_chunks('vehiculos_grande', older_than =&gt; now() - INTERVAL '5 days');</a:t>
             </a:r>
           </a:p>
           <a:p>
@@ -6392,7 +6392,7 @@
                 </a:solidFill>
                 <a:latin typeface="Helvetica Neue"/>
               </a:rPr>
-              <a:t>SELECT add_retention_policy('vehiculos_gorda', drop_after =&gt; INTERVAL '5 days');</a:t>
+              <a:t>SELECT add_retention_policy('vehiculos_grande', drop_after =&gt; INTERVAL '5 days');</a:t>
             </a:r>
           </a:p>
           <a:p>
@@ -6417,7 +6417,7 @@
                 </a:solidFill>
                 <a:latin typeface="Helvetica Neue"/>
               </a:rPr>
-              <a:t>CALL run_job(1001);   SELECT remove_retention_policy('vehiculos_gorda');</a:t>
+              <a:t>CALL run_job(1001);   SELECT remove_retention_policy('vehiculos_grande');</a:t>
             </a:r>
           </a:p>
         </p:txBody>
@@ -18924,7 +18924,7 @@
                 </a:solidFill>
                 <a:latin typeface="Helvetica Neue"/>
               </a:rPr>
-              <a:t>ALTER TABLE vehiculos_gorda SET (timescaledb.compress, segmentby='auto_id', orderby='ts DESC');</a:t>
+              <a:t>ALTER TABLE vehiculos_grande SET (timescaledb.compress, segmentby='auto_id', orderby='ts DESC');</a:t>
             </a:r>
           </a:p>
         </p:txBody>
@@ -19075,7 +19075,7 @@
                 </a:solidFill>
                 <a:latin typeface="Helvetica Neue"/>
               </a:rPr>
-              <a:t>vehiculos_gorda: 3 chunks de 3 días, 2 comprimidos y 1 de control</a:t>
+              <a:t>vehiculos_grande: 3 chunks de 3 días, 2 comprimidos y 1 de control</a:t>
             </a:r>
           </a:p>
         </p:txBody>

</xml_diff>

<commit_message>
PPT: quitar ids de jobs (1000/1001/1002/1004) y hablar de politicas/procesos
</commit_message>
<xml_diff>
--- a/presentacion/TimescaleDB-PPT-Javier.pptx
+++ b/presentacion/TimescaleDB-PPT-Javier.pptx
@@ -3625,7 +3625,7 @@
                 </a:solidFill>
                 <a:latin typeface="Helvetica Neue"/>
               </a:rPr>
-              <a:t>La política de compresión — job 1000, que se ocupa de todo</a:t>
+              <a:t>La política de compresión: se ocupa de todo sola</a:t>
             </a:r>
           </a:p>
         </p:txBody>
@@ -3953,7 +3953,7 @@
                 </a:solidFill>
                 <a:latin typeface="Helvetica Neue"/>
               </a:rPr>
-              <a:t>       schedule_interval =&gt; INTERVAL '24 hours');  --→ job 1000</a:t>
+              <a:t>       schedule_interval =&gt; INTERVAL '24 hours');  -- el id lo asigna Timescale</a:t>
             </a:r>
           </a:p>
           <a:p>
@@ -3994,7 +3994,7 @@
                 </a:solidFill>
                 <a:latin typeface="Helvetica Neue"/>
               </a:rPr>
-              <a:t>CALL run_job(1000);            -- forzarlo a mano (procedimiento)</a:t>
+              <a:t>CALL run_job(&lt;job_id&gt;);       -- forzarlo a mano (procedimiento)</a:t>
             </a:r>
           </a:p>
           <a:p>
@@ -4019,7 +4019,7 @@
                 </a:solidFill>
                 <a:latin typeface="Helvetica Neue"/>
               </a:rPr>
-              <a:t>SELECT alter_job(1000, scheduled =&gt; false);         -- pausar</a:t>
+              <a:t>SELECT alter_job(&lt;job_id&gt;, scheduled =&gt; false);     -- pausar</a:t>
             </a:r>
           </a:p>
           <a:p>
@@ -4214,7 +4214,7 @@
                 </a:solidFill>
                 <a:latin typeface="Helvetica Neue"/>
               </a:rPr>
-              <a:t>: nunca toca la ventana reciente (por eso el 3003 sigue sin comprimir).</a:t>
+              <a:t>: nunca toca la ventana reciente (por eso el chunk de control sigue sin comprimir).</a:t>
             </a:r>
           </a:p>
           <a:p>
@@ -4275,7 +4275,7 @@
                 </a:solidFill>
                 <a:latin typeface="Helvetica Neue"/>
               </a:rPr>
-              <a:t> muestran la ejecución en vivo: Success, tiempos, siguiente arranque.</a:t>
+              <a:t> muestran la ejecución en vivo: éxito, tiempos, siguiente arranque.</a:t>
             </a:r>
           </a:p>
         </p:txBody>
@@ -4394,7 +4394,7 @@
                 </a:solidFill>
                 <a:latin typeface="Helvetica Neue"/>
               </a:rPr>
-              <a:t>job 1000 · Success</a:t>
+              <a:t>Éxito (Success)</a:t>
             </a:r>
           </a:p>
           <a:p>
@@ -4419,7 +4419,7 @@
                 </a:solidFill>
                 <a:latin typeface="Helvetica Neue"/>
               </a:rPr>
-              <a:t>last_run ≈ al crearse, next_start +24 h</a:t>
+              <a:t>arrancó al crearse y vuelve cada 24 h</a:t>
             </a:r>
           </a:p>
           <a:p>
@@ -6023,7 +6023,7 @@
                 </a:solidFill>
                 <a:latin typeface="Helvetica Neue"/>
               </a:rPr>
-              <a:t>Retención / autopurga: que lo viejo desaparezca solo — job 1001</a:t>
+              <a:t>Retención / autopurga: que lo viejo desaparezca solo</a:t>
             </a:r>
           </a:p>
         </p:txBody>
@@ -6367,7 +6367,7 @@
                 </a:solidFill>
                 <a:latin typeface="Helvetica Neue"/>
               </a:rPr>
-              <a:t>-- Automático: política de retención → job 1001 (cada 24 h)</a:t>
+              <a:t>-- Automático: política de retención (se repite cada 24 h)</a:t>
             </a:r>
           </a:p>
           <a:p>
@@ -6417,7 +6417,7 @@
                 </a:solidFill>
                 <a:latin typeface="Helvetica Neue"/>
               </a:rPr>
-              <a:t>CALL run_job(1001);   SELECT remove_retention_policy('vehiculos_grande');</a:t>
+              <a:t>CALL run_job(&lt;job_id&gt;);   SELECT remove_retention_policy('vehiculos_grande');</a:t>
             </a:r>
           </a:p>
         </p:txBody>
@@ -6562,7 +6562,32 @@
                 </a:solidFill>
                 <a:latin typeface="Helvetica Neue"/>
               </a:rPr>
-              <a:t>; la autopurga se llevó exactamente un chunk (</a:t>
+              <a:t>; la autopurga se llevó exactamente el más antiguo.</a:t>
+            </a:r>
+          </a:p>
+          <a:p>
+            <a:pPr algn="l">
+              <a:spcBef>
+                <a:spcPts val="0"/>
+              </a:spcBef>
+              <a:spcAft>
+                <a:spcPts val="0"/>
+              </a:spcAft>
+              <a:defRPr sz="1500" b="0">
+                <a:solidFill>
+                  <a:srgbClr val="E2E8F0"/>
+                </a:solidFill>
+                <a:latin typeface="Helvetica Neue"/>
+              </a:defRPr>
+            </a:pPr>
+            <a:r>
+              <a:rPr>
+                <a:solidFill>
+                  <a:srgbClr val="E2E8F0"/>
+                </a:solidFill>
+                <a:latin typeface="Helvetica Neue"/>
+              </a:rPr>
+              <a:t>·  Compresión y retención son </a:t>
             </a:r>
             <a:r>
               <a:rPr b="1">
@@ -6571,50 +6596,7 @@
                 </a:solidFill>
                 <a:latin typeface="Helvetica Neue"/>
               </a:rPr>
-              <a:t>−518.405 filas</a:t>
-            </a:r>
-            <a:r>
-              <a:rPr>
-                <a:solidFill>
-                  <a:srgbClr val="E2E8F0"/>
-                </a:solidFill>
-                <a:latin typeface="Helvetica Neue"/>
-              </a:rPr>
-              <a:t>).</a:t>
-            </a:r>
-          </a:p>
-          <a:p>
-            <a:pPr algn="l">
-              <a:spcBef>
-                <a:spcPts val="0"/>
-              </a:spcBef>
-              <a:spcAft>
-                <a:spcPts val="0"/>
-              </a:spcAft>
-              <a:defRPr sz="1500" b="0">
-                <a:solidFill>
-                  <a:srgbClr val="E2E8F0"/>
-                </a:solidFill>
-                <a:latin typeface="Helvetica Neue"/>
-              </a:defRPr>
-            </a:pPr>
-            <a:r>
-              <a:rPr>
-                <a:solidFill>
-                  <a:srgbClr val="E2E8F0"/>
-                </a:solidFill>
-                <a:latin typeface="Helvetica Neue"/>
-              </a:rPr>
-              <a:t>·  Compresión (1000) y retención (1001) son </a:t>
-            </a:r>
-            <a:r>
-              <a:rPr b="1">
-                <a:solidFill>
-                  <a:srgbClr val="FBBF24"/>
-                </a:solidFill>
-                <a:latin typeface="Helvetica Neue"/>
-              </a:rPr>
-              <a:t>dos jobs distintos que se complementan</a:t>
+              <a:t>dos políticas que se complementan</a:t>
             </a:r>
             <a:r>
               <a:rPr>
@@ -8659,7 +8641,7 @@
                 </a:solidFill>
                 <a:latin typeface="Helvetica Neue"/>
               </a:rPr>
-              <a:t>Continuous aggregates: el resumen precalculado — job 1002</a:t>
+              <a:t>Continuous aggregates: el resumen precalculado</a:t>
             </a:r>
           </a:p>
         </p:txBody>
@@ -9338,7 +9320,7 @@
                 </a:solidFill>
                 <a:latin typeface="Helvetica Neue"/>
               </a:rPr>
-              <a:t>  schedule_interval =&gt; INTERVAL '1 hour');  --→ job 1002</a:t>
+              <a:t>  schedule_interval =&gt; INTERVAL '1 hour');  -- refresco cada hora</a:t>
             </a:r>
           </a:p>
         </p:txBody>
@@ -11803,7 +11785,7 @@
                 </a:solidFill>
                 <a:latin typeface="Helvetica Neue"/>
               </a:rPr>
-              <a:t>Jobs personalizados: Timescale como cron de PostgreSQL — job 1004</a:t>
+              <a:t>Jobs personalizados: Timescale como cron de PostgreSQL</a:t>
             </a:r>
           </a:p>
         </p:txBody>
@@ -12106,7 +12088,7 @@
                 </a:solidFill>
                 <a:latin typeface="Helvetica Neue"/>
               </a:rPr>
-              <a:t>               schedule_interval =&gt; INTERVAL '1 hour');  --→ 1003</a:t>
+              <a:t>               schedule_interval =&gt; INTERVAL '1 hour');  -- se registra solo</a:t>
             </a:r>
           </a:p>
           <a:p>
@@ -12131,7 +12113,7 @@
                 </a:solidFill>
                 <a:latin typeface="Helvetica Neue"/>
               </a:rPr>
-              <a:t>CALL run_job(1003);                -- rellena kpi_velocidad (10 filas)</a:t>
+              <a:t>CALL run_job(&lt;job_id&gt;);          -- rellena kpi_velocidad (10 filas)</a:t>
             </a:r>
           </a:p>
           <a:p>
@@ -12156,7 +12138,7 @@
                 </a:solidFill>
                 <a:latin typeface="Helvetica Neue"/>
               </a:rPr>
-              <a:t>SELECT alter_job(1003, scheduled =&gt; false);  SELECT delete_job(1003);</a:t>
+              <a:t>SELECT alter_job(&lt;job_id&gt;, scheduled =&gt; false);  SELECT delete_job(&lt;job_id&gt;);</a:t>
             </a:r>
           </a:p>
           <a:p>
@@ -12181,7 +12163,7 @@
                 </a:solidFill>
                 <a:latin typeface="Helvetica Neue"/>
               </a:rPr>
-              <a:t>SELECT add_job(...);               -- recreado → 1004</a:t>
+              <a:t>SELECT add_job(...);             -- recreado → otro id</a:t>
             </a:r>
           </a:p>
         </p:txBody>
@@ -12684,7 +12666,7 @@
                 </a:solidFill>
                 <a:latin typeface="Helvetica Neue"/>
               </a:rPr>
-              <a:t>El círculo de la telemetría: 4 jobs que mantienen viva la historia</a:t>
+              <a:t>El círculo de la telemetría: 4 políticas que mantienen viva la historia</a:t>
             </a:r>
           </a:p>
         </p:txBody>
@@ -13246,7 +13228,7 @@
                 </a:solidFill>
                 <a:latin typeface="Helvetica Neue"/>
               </a:rPr>
-              <a:t>COMPRIME (1000)</a:t>
+              <a:t>COMPRIME</a:t>
             </a:r>
           </a:p>
         </p:txBody>
@@ -13388,7 +13370,7 @@
                 </a:solidFill>
                 <a:latin typeface="Helvetica Neue"/>
               </a:rPr>
-              <a:t>AGREGA (1002)</a:t>
+              <a:t>AGREGA</a:t>
             </a:r>
           </a:p>
         </p:txBody>
@@ -13530,7 +13512,7 @@
                 </a:solidFill>
                 <a:latin typeface="Helvetica Neue"/>
               </a:rPr>
-              <a:t>BORRA (1001)</a:t>
+              <a:t>BORRA</a:t>
             </a:r>
           </a:p>
         </p:txBody>
@@ -13672,7 +13654,7 @@
                 </a:solidFill>
                 <a:latin typeface="Helvetica Neue"/>
               </a:rPr>
-              <a:t>KPI (1004)</a:t>
+              <a:t>KPI</a:t>
             </a:r>
           </a:p>
         </p:txBody>
@@ -13816,79 +13798,7 @@
                 </a:solidFill>
                 <a:latin typeface="Helvetica Neue"/>
               </a:rPr>
-              <a:t>Panel final de jobs (todo vivo): </a:t>
-            </a:r>
-            <a:r>
-              <a:rPr b="1">
-                <a:solidFill>
-                  <a:srgbClr val="FBBF24"/>
-                </a:solidFill>
-                <a:latin typeface="Helvetica Neue"/>
-              </a:rPr>
-              <a:t>1000</a:t>
-            </a:r>
-            <a:r>
-              <a:rPr>
-                <a:solidFill>
-                  <a:srgbClr val="E2E8F0"/>
-                </a:solidFill>
-                <a:latin typeface="Helvetica Neue"/>
-              </a:rPr>
-              <a:t> compresión · </a:t>
-            </a:r>
-            <a:r>
-              <a:rPr b="1">
-                <a:solidFill>
-                  <a:srgbClr val="FBBF24"/>
-                </a:solidFill>
-                <a:latin typeface="Helvetica Neue"/>
-              </a:rPr>
-              <a:t>1001</a:t>
-            </a:r>
-            <a:r>
-              <a:rPr>
-                <a:solidFill>
-                  <a:srgbClr val="E2E8F0"/>
-                </a:solidFill>
-                <a:latin typeface="Helvetica Neue"/>
-              </a:rPr>
-              <a:t> retención · </a:t>
-            </a:r>
-            <a:r>
-              <a:rPr b="1">
-                <a:solidFill>
-                  <a:srgbClr val="FBBF24"/>
-                </a:solidFill>
-                <a:latin typeface="Helvetica Neue"/>
-              </a:rPr>
-              <a:t>1002</a:t>
-            </a:r>
-            <a:r>
-              <a:rPr>
-                <a:solidFill>
-                  <a:srgbClr val="E2E8F0"/>
-                </a:solidFill>
-                <a:latin typeface="Helvetica Neue"/>
-              </a:rPr>
-              <a:t> refresh cagg · </a:t>
-            </a:r>
-            <a:r>
-              <a:rPr b="1">
-                <a:solidFill>
-                  <a:srgbClr val="FBBF24"/>
-                </a:solidFill>
-                <a:latin typeface="Helvetica Neue"/>
-              </a:rPr>
-              <a:t>1004</a:t>
-            </a:r>
-            <a:r>
-              <a:rPr>
-                <a:solidFill>
-                  <a:srgbClr val="E2E8F0"/>
-                </a:solidFill>
-                <a:latin typeface="Helvetica Neue"/>
-              </a:rPr>
-              <a:t> KPI custom.</a:t>
+              <a:t>Cuatro procesos de fondo vivos de principio a fin: compresión, retención, refresco del cagg y el KPI custom (cada uno con su id, asignado por Timescale).</a:t>
             </a:r>
           </a:p>
           <a:p>
@@ -15367,7 +15277,7 @@
                 </a:solidFill>
                 <a:latin typeface="Helvetica Neue"/>
               </a:rPr>
-              <a:t>05   Política de compresión — el job 1000</a:t>
+              <a:t>05   Política de compresión — el trabajo en segundo plano</a:t>
             </a:r>
           </a:p>
           <a:p>
@@ -15440,7 +15350,7 @@
                 </a:solidFill>
                 <a:latin typeface="Helvetica Neue"/>
               </a:rPr>
-              <a:t>01   Retención / autopurga — el job 1001</a:t>
+              <a:t>01   Retención / autopurga — el historial se borra solo</a:t>
             </a:r>
           </a:p>
           <a:p>
@@ -15490,7 +15400,7 @@
                 </a:solidFill>
                 <a:latin typeface="Helvetica Neue"/>
               </a:rPr>
-              <a:t>03   Continuous aggregates — el job 1002</a:t>
+              <a:t>03   Continuous aggregates — el resumen precalculado</a:t>
             </a:r>
           </a:p>
           <a:p>
@@ -21290,7 +21200,7 @@
                 </a:solidFill>
                 <a:latin typeface="Helvetica Neue"/>
               </a:rPr>
-              <a:t> o la política de compresión (job 1000).</a:t>
+              <a:t> o la política de compresión en segundo plano.</a:t>
             </a:r>
           </a:p>
           <a:p>

</xml_diff>

<commit_message>
PPT slide 7: dejar claro que el algoritmo por defecto lo elige Timescale por tipo (DELTADELTA/GORILLA/DICTIONARY/BOOL/UUID segun catalogo 2.30)
</commit_message>
<xml_diff>
--- a/presentacion/TimescaleDB-PPT-Javier.pptx
+++ b/presentacion/TimescaleDB-PPT-Javier.pptx
@@ -18402,7 +18402,25 @@
                 </a:solidFill>
                 <a:latin typeface="Helvetica Neue"/>
               </a:rPr>
-              <a:t>Algoritmos automáticos por tipo:</a:t>
+              <a:t>Algoritmo por defecto: Timescale lo elige solo al comprimir, </a:t>
+            </a:r>
+            <a:r>
+              <a:rPr b="1">
+                <a:solidFill>
+                  <a:srgbClr val="FBBF24"/>
+                </a:solidFill>
+                <a:latin typeface="Helvetica Neue"/>
+              </a:rPr>
+              <a:t>según el tipo de cada columna</a:t>
+            </a:r>
+            <a:r>
+              <a:rPr>
+                <a:solidFill>
+                  <a:srgbClr val="E2E8F0"/>
+                </a:solidFill>
+                <a:latin typeface="Helvetica Neue"/>
+              </a:rPr>
+              <a:t> (catálogo 2.30):</a:t>
             </a:r>
           </a:p>
           <a:p>
@@ -18427,16 +18445,34 @@
                 </a:solidFill>
                 <a:latin typeface="Helvetica Neue"/>
               </a:rPr>
-              <a:t>delta-of-delta + simple-8b + RLE</a:t>
-            </a:r>
-            <a:r>
-              <a:rPr>
-                <a:solidFill>
-                  <a:srgbClr val="E2E8F0"/>
-                </a:solidFill>
-                <a:latin typeface="Helvetica Neue"/>
-              </a:rPr>
-              <a:t> → enteros, timestamps, bool</a:t>
+              <a:t>DELTADELTA</a:t>
+            </a:r>
+            <a:r>
+              <a:rPr>
+                <a:solidFill>
+                  <a:srgbClr val="E2E8F0"/>
+                </a:solidFill>
+                <a:latin typeface="Helvetica Neue"/>
+              </a:rPr>
+              <a:t> + simple-8b + RLE → enteros y timestamps (el </a:t>
+            </a:r>
+            <a:r>
+              <a:rPr sz="1300" b="1">
+                <a:solidFill>
+                  <a:srgbClr val="7DD3FC"/>
+                </a:solidFill>
+                <a:latin typeface="Helvetica Neue"/>
+              </a:rPr>
+              <a:t>ts</a:t>
+            </a:r>
+            <a:r>
+              <a:rPr>
+                <a:solidFill>
+                  <a:srgbClr val="E2E8F0"/>
+                </a:solidFill>
+                <a:latin typeface="Helvetica Neue"/>
+              </a:rPr>
+              <a:t> pasa de 64 bits a ~1)</a:t>
             </a:r>
           </a:p>
           <a:p>
@@ -18461,16 +18497,16 @@
                 </a:solidFill>
                 <a:latin typeface="Helvetica Neue"/>
               </a:rPr>
-              <a:t>XOR (Gorilla)</a:t>
-            </a:r>
-            <a:r>
-              <a:rPr>
-                <a:solidFill>
-                  <a:srgbClr val="E2E8F0"/>
-                </a:solidFill>
-                <a:latin typeface="Helvetica Neue"/>
-              </a:rPr>
-              <a:t> → flotantes: velocidad, presiones, temperaturas</a:t>
+              <a:t>GORILLA</a:t>
+            </a:r>
+            <a:r>
+              <a:rPr>
+                <a:solidFill>
+                  <a:srgbClr val="E2E8F0"/>
+                </a:solidFill>
+                <a:latin typeface="Helvetica Neue"/>
+              </a:rPr>
+              <a:t> (XOR) → flotantes: velocidad, presiones, temperaturas</a:t>
             </a:r>
           </a:p>
           <a:p>
@@ -18479,6 +18515,49 @@
                 <a:spcPts val="0"/>
               </a:spcBef>
               <a:spcAft>
+                <a:spcPts val="200"/>
+              </a:spcAft>
+              <a:defRPr sz="1300" b="0">
+                <a:solidFill>
+                  <a:srgbClr val="E2E8F0"/>
+                </a:solidFill>
+                <a:latin typeface="Helvetica Neue"/>
+              </a:defRPr>
+            </a:pPr>
+            <a:r>
+              <a:rPr sz="1300" b="1">
+                <a:solidFill>
+                  <a:srgbClr val="7DD3FC"/>
+                </a:solidFill>
+                <a:latin typeface="Helvetica Neue"/>
+              </a:rPr>
+              <a:t>DICTIONARY</a:t>
+            </a:r>
+            <a:r>
+              <a:rPr>
+                <a:solidFill>
+                  <a:srgbClr val="E2E8F0"/>
+                </a:solidFill>
+                <a:latin typeface="Helvetica Neue"/>
+              </a:rPr>
+              <a:t> → baja cardinalidad: </a:t>
+            </a:r>
+            <a:r>
+              <a:rPr sz="1300" b="1">
+                <a:solidFill>
+                  <a:srgbClr val="7DD3FC"/>
+                </a:solidFill>
+                <a:latin typeface="Helvetica Neue"/>
+              </a:rPr>
+              <a:t>auto_id</a:t>
+            </a:r>
+          </a:p>
+          <a:p>
+            <a:pPr algn="l" lvl="1">
+              <a:spcBef>
+                <a:spcPts val="0"/>
+              </a:spcBef>
+              <a:spcAft>
                 <a:spcPts val="800"/>
               </a:spcAft>
               <a:defRPr sz="1300" b="0">
@@ -18495,16 +18574,52 @@
                 </a:solidFill>
                 <a:latin typeface="Helvetica Neue"/>
               </a:rPr>
-              <a:t>diccionario</a:t>
-            </a:r>
-            <a:r>
-              <a:rPr>
-                <a:solidFill>
-                  <a:srgbClr val="E2E8F0"/>
-                </a:solidFill>
-                <a:latin typeface="Helvetica Neue"/>
-              </a:rPr>
-              <a:t> → baja cardinalidad: auto_id, rpm</a:t>
+              <a:t>BOOL</a:t>
+            </a:r>
+            <a:r>
+              <a:rPr>
+                <a:solidFill>
+                  <a:srgbClr val="E2E8F0"/>
+                </a:solidFill>
+                <a:latin typeface="Helvetica Neue"/>
+              </a:rPr>
+              <a:t> / </a:t>
+            </a:r>
+            <a:r>
+              <a:rPr sz="1300" b="1">
+                <a:solidFill>
+                  <a:srgbClr val="7DD3FC"/>
+                </a:solidFill>
+                <a:latin typeface="Helvetica Neue"/>
+              </a:rPr>
+              <a:t>UUID</a:t>
+            </a:r>
+            <a:r>
+              <a:rPr>
+                <a:solidFill>
+                  <a:srgbClr val="E2E8F0"/>
+                </a:solidFill>
+                <a:latin typeface="Helvetica Neue"/>
+              </a:rPr>
+              <a:t> → bools e ids; </a:t>
+            </a:r>
+            <a:r>
+              <a:rPr sz="1300" b="1">
+                <a:solidFill>
+                  <a:srgbClr val="7DD3FC"/>
+                </a:solidFill>
+                <a:latin typeface="Helvetica Neue"/>
+              </a:rPr>
+              <a:t>ARRAY</a:t>
+            </a:r>
+            <a:r>
+              <a:rPr>
+                <a:solidFill>
+                  <a:srgbClr val="E2E8F0"/>
+                </a:solidFill>
+                <a:latin typeface="Helvetica Neue"/>
+              </a:rPr>
+              <a:t> solo para filtros/índices</a:t>
             </a:r>
           </a:p>
           <a:p>
@@ -18529,7 +18644,7 @@
                 </a:solidFill>
                 <a:latin typeface="Helvetica Neue"/>
               </a:rPr>
-              <a:t>Se configura con </a:t>
+              <a:t>Tú no pides el algoritmo (solo </a:t>
             </a:r>
             <a:r>
               <a:rPr sz="1500" b="1">
@@ -18547,7 +18662,7 @@
                 </a:solidFill>
                 <a:latin typeface="Helvetica Neue"/>
               </a:rPr>
-              <a:t> (por coche) y </a:t>
+              <a:t>/</a:t>
             </a:r>
             <a:r>
               <a:rPr sz="1500" b="1">
@@ -18565,7 +18680,25 @@
                 </a:solidFill>
                 <a:latin typeface="Helvetica Neue"/>
               </a:rPr>
-              <a:t> (ts DESC).</a:t>
+              <a:t>): </a:t>
+            </a:r>
+            <a:r>
+              <a:rPr sz="1500" b="1">
+                <a:solidFill>
+                  <a:srgbClr val="7DD3FC"/>
+                </a:solidFill>
+                <a:latin typeface="Helvetica Neue"/>
+              </a:rPr>
+              <a:t>timescaledb_information.compression_settings</a:t>
+            </a:r>
+            <a:r>
+              <a:rPr>
+                <a:solidFill>
+                  <a:srgbClr val="E2E8F0"/>
+                </a:solidFill>
+                <a:latin typeface="Helvetica Neue"/>
+              </a:rPr>
+              <a:t> muestra lo aplicado.</a:t>
             </a:r>
           </a:p>
           <a:p>

</xml_diff>

<commit_message>
PPT: subir el titulo para que la linea amber no lo cruce
</commit_message>
<xml_diff>
--- a/presentacion/TimescaleDB-PPT-Javier.pptx
+++ b/presentacion/TimescaleDB-PPT-Javier.pptx
@@ -3549,7 +3549,7 @@
         </p:nvSpPr>
         <p:spPr>
           <a:xfrm>
-            <a:off x="548640" y="457200"/>
+            <a:off x="548640" y="384048"/>
             <a:ext cx="11064240" cy="640080"/>
           </a:xfrm>
           <a:prstGeom prst="rect">
@@ -3590,7 +3590,7 @@
         </p:nvSpPr>
         <p:spPr>
           <a:xfrm>
-            <a:off x="548640" y="1042416"/>
+            <a:off x="548640" y="932688"/>
             <a:ext cx="11064240" cy="365760"/>
           </a:xfrm>
           <a:prstGeom prst="rect">
@@ -3638,7 +3638,7 @@
         </p:nvSpPr>
         <p:spPr>
           <a:xfrm>
-            <a:off x="548640" y="813816"/>
+            <a:off x="548640" y="868680"/>
             <a:ext cx="960120" cy="41148"/>
           </a:xfrm>
           <a:prstGeom prst="rect">
@@ -4519,7 +4519,7 @@
         </p:nvSpPr>
         <p:spPr>
           <a:xfrm>
-            <a:off x="548640" y="457200"/>
+            <a:off x="548640" y="384048"/>
             <a:ext cx="11064240" cy="640080"/>
           </a:xfrm>
           <a:prstGeom prst="rect">
@@ -4560,7 +4560,7 @@
         </p:nvSpPr>
         <p:spPr>
           <a:xfrm>
-            <a:off x="548640" y="1042416"/>
+            <a:off x="548640" y="932688"/>
             <a:ext cx="11064240" cy="365760"/>
           </a:xfrm>
           <a:prstGeom prst="rect">
@@ -4608,7 +4608,7 @@
         </p:nvSpPr>
         <p:spPr>
           <a:xfrm>
-            <a:off x="548640" y="813816"/>
+            <a:off x="548640" y="868680"/>
             <a:ext cx="960120" cy="41148"/>
           </a:xfrm>
           <a:prstGeom prst="rect">
@@ -5947,7 +5947,7 @@
         </p:nvSpPr>
         <p:spPr>
           <a:xfrm>
-            <a:off x="548640" y="457200"/>
+            <a:off x="548640" y="384048"/>
             <a:ext cx="11064240" cy="640080"/>
           </a:xfrm>
           <a:prstGeom prst="rect">
@@ -5988,7 +5988,7 @@
         </p:nvSpPr>
         <p:spPr>
           <a:xfrm>
-            <a:off x="548640" y="1042416"/>
+            <a:off x="548640" y="932688"/>
             <a:ext cx="11064240" cy="365760"/>
           </a:xfrm>
           <a:prstGeom prst="rect">
@@ -6036,7 +6036,7 @@
         </p:nvSpPr>
         <p:spPr>
           <a:xfrm>
-            <a:off x="548640" y="813816"/>
+            <a:off x="548640" y="868680"/>
             <a:ext cx="960120" cy="41148"/>
           </a:xfrm>
           <a:prstGeom prst="rect">
@@ -6817,7 +6817,7 @@
         </p:nvSpPr>
         <p:spPr>
           <a:xfrm>
-            <a:off x="548640" y="457200"/>
+            <a:off x="548640" y="384048"/>
             <a:ext cx="11064240" cy="640080"/>
           </a:xfrm>
           <a:prstGeom prst="rect">
@@ -6858,7 +6858,7 @@
         </p:nvSpPr>
         <p:spPr>
           <a:xfrm>
-            <a:off x="548640" y="1042416"/>
+            <a:off x="548640" y="932688"/>
             <a:ext cx="11064240" cy="365760"/>
           </a:xfrm>
           <a:prstGeom prst="rect">
@@ -6906,7 +6906,7 @@
         </p:nvSpPr>
         <p:spPr>
           <a:xfrm>
-            <a:off x="548640" y="813816"/>
+            <a:off x="548640" y="868680"/>
             <a:ext cx="960120" cy="41148"/>
           </a:xfrm>
           <a:prstGeom prst="rect">
@@ -8565,7 +8565,7 @@
         </p:nvSpPr>
         <p:spPr>
           <a:xfrm>
-            <a:off x="548640" y="457200"/>
+            <a:off x="548640" y="384048"/>
             <a:ext cx="11064240" cy="640080"/>
           </a:xfrm>
           <a:prstGeom prst="rect">
@@ -8606,7 +8606,7 @@
         </p:nvSpPr>
         <p:spPr>
           <a:xfrm>
-            <a:off x="548640" y="1042416"/>
+            <a:off x="548640" y="932688"/>
             <a:ext cx="11064240" cy="365760"/>
           </a:xfrm>
           <a:prstGeom prst="rect">
@@ -8654,7 +8654,7 @@
         </p:nvSpPr>
         <p:spPr>
           <a:xfrm>
-            <a:off x="548640" y="813816"/>
+            <a:off x="548640" y="868680"/>
             <a:ext cx="960120" cy="41148"/>
           </a:xfrm>
           <a:prstGeom prst="rect">
@@ -9564,7 +9564,7 @@
         </p:nvSpPr>
         <p:spPr>
           <a:xfrm>
-            <a:off x="548640" y="457200"/>
+            <a:off x="548640" y="384048"/>
             <a:ext cx="11064240" cy="640080"/>
           </a:xfrm>
           <a:prstGeom prst="rect">
@@ -9605,7 +9605,7 @@
         </p:nvSpPr>
         <p:spPr>
           <a:xfrm>
-            <a:off x="548640" y="1042416"/>
+            <a:off x="548640" y="932688"/>
             <a:ext cx="11064240" cy="365760"/>
           </a:xfrm>
           <a:prstGeom prst="rect">
@@ -9653,7 +9653,7 @@
         </p:nvSpPr>
         <p:spPr>
           <a:xfrm>
-            <a:off x="548640" y="813816"/>
+            <a:off x="548640" y="868680"/>
             <a:ext cx="960120" cy="41148"/>
           </a:xfrm>
           <a:prstGeom prst="rect">
@@ -11709,7 +11709,7 @@
         </p:nvSpPr>
         <p:spPr>
           <a:xfrm>
-            <a:off x="548640" y="457200"/>
+            <a:off x="548640" y="384048"/>
             <a:ext cx="11064240" cy="640080"/>
           </a:xfrm>
           <a:prstGeom prst="rect">
@@ -11750,7 +11750,7 @@
         </p:nvSpPr>
         <p:spPr>
           <a:xfrm>
-            <a:off x="548640" y="1042416"/>
+            <a:off x="548640" y="932688"/>
             <a:ext cx="11064240" cy="365760"/>
           </a:xfrm>
           <a:prstGeom prst="rect">
@@ -11798,7 +11798,7 @@
         </p:nvSpPr>
         <p:spPr>
           <a:xfrm>
-            <a:off x="548640" y="813816"/>
+            <a:off x="548640" y="868680"/>
             <a:ext cx="960120" cy="41148"/>
           </a:xfrm>
           <a:prstGeom prst="rect">
@@ -12638,7 +12638,7 @@
         </p:nvSpPr>
         <p:spPr>
           <a:xfrm>
-            <a:off x="548640" y="457200"/>
+            <a:off x="548640" y="384048"/>
             <a:ext cx="11064240" cy="640080"/>
           </a:xfrm>
           <a:prstGeom prst="rect">
@@ -12679,7 +12679,7 @@
         </p:nvSpPr>
         <p:spPr>
           <a:xfrm>
-            <a:off x="548640" y="813816"/>
+            <a:off x="548640" y="868680"/>
             <a:ext cx="960120" cy="41148"/>
           </a:xfrm>
           <a:prstGeom prst="rect">
@@ -14480,7 +14480,7 @@
         </p:nvSpPr>
         <p:spPr>
           <a:xfrm>
-            <a:off x="548640" y="457200"/>
+            <a:off x="548640" y="384048"/>
             <a:ext cx="11064240" cy="640080"/>
           </a:xfrm>
           <a:prstGeom prst="rect">
@@ -14521,7 +14521,7 @@
         </p:nvSpPr>
         <p:spPr>
           <a:xfrm>
-            <a:off x="548640" y="813816"/>
+            <a:off x="548640" y="868680"/>
             <a:ext cx="960120" cy="41148"/>
           </a:xfrm>
           <a:prstGeom prst="rect">
@@ -14917,7 +14917,7 @@
         </p:nvSpPr>
         <p:spPr>
           <a:xfrm>
-            <a:off x="548640" y="457200"/>
+            <a:off x="548640" y="384048"/>
             <a:ext cx="11064240" cy="640080"/>
           </a:xfrm>
           <a:prstGeom prst="rect">
@@ -14958,7 +14958,7 @@
         </p:nvSpPr>
         <p:spPr>
           <a:xfrm>
-            <a:off x="548640" y="813816"/>
+            <a:off x="548640" y="868680"/>
             <a:ext cx="960120" cy="41148"/>
           </a:xfrm>
           <a:prstGeom prst="rect">
@@ -15598,7 +15598,7 @@
         </p:nvSpPr>
         <p:spPr>
           <a:xfrm>
-            <a:off x="548640" y="457200"/>
+            <a:off x="548640" y="384048"/>
             <a:ext cx="11064240" cy="640080"/>
           </a:xfrm>
           <a:prstGeom prst="rect">
@@ -15639,7 +15639,7 @@
         </p:nvSpPr>
         <p:spPr>
           <a:xfrm>
-            <a:off x="548640" y="813816"/>
+            <a:off x="548640" y="868680"/>
             <a:ext cx="960120" cy="41148"/>
           </a:xfrm>
           <a:prstGeom prst="rect">
@@ -16426,7 +16426,7 @@
         </p:nvSpPr>
         <p:spPr>
           <a:xfrm>
-            <a:off x="548640" y="457200"/>
+            <a:off x="548640" y="384048"/>
             <a:ext cx="11064240" cy="640080"/>
           </a:xfrm>
           <a:prstGeom prst="rect">
@@ -16467,7 +16467,7 @@
         </p:nvSpPr>
         <p:spPr>
           <a:xfrm>
-            <a:off x="548640" y="1042416"/>
+            <a:off x="548640" y="932688"/>
             <a:ext cx="11064240" cy="365760"/>
           </a:xfrm>
           <a:prstGeom prst="rect">
@@ -16515,7 +16515,7 @@
         </p:nvSpPr>
         <p:spPr>
           <a:xfrm>
-            <a:off x="548640" y="813816"/>
+            <a:off x="548640" y="868680"/>
             <a:ext cx="960120" cy="41148"/>
           </a:xfrm>
           <a:prstGeom prst="rect">
@@ -17366,7 +17366,7 @@
         </p:nvSpPr>
         <p:spPr>
           <a:xfrm>
-            <a:off x="548640" y="457200"/>
+            <a:off x="548640" y="384048"/>
             <a:ext cx="11064240" cy="640080"/>
           </a:xfrm>
           <a:prstGeom prst="rect">
@@ -17407,7 +17407,7 @@
         </p:nvSpPr>
         <p:spPr>
           <a:xfrm>
-            <a:off x="548640" y="1042416"/>
+            <a:off x="548640" y="932688"/>
             <a:ext cx="11064240" cy="365760"/>
           </a:xfrm>
           <a:prstGeom prst="rect">
@@ -17455,7 +17455,7 @@
         </p:nvSpPr>
         <p:spPr>
           <a:xfrm>
-            <a:off x="548640" y="813816"/>
+            <a:off x="548640" y="868680"/>
             <a:ext cx="960120" cy="41148"/>
           </a:xfrm>
           <a:prstGeom prst="rect">
@@ -17997,7 +17997,7 @@
         </p:nvSpPr>
         <p:spPr>
           <a:xfrm>
-            <a:off x="548640" y="457200"/>
+            <a:off x="548640" y="384048"/>
             <a:ext cx="11064240" cy="640080"/>
           </a:xfrm>
           <a:prstGeom prst="rect">
@@ -18038,7 +18038,7 @@
         </p:nvSpPr>
         <p:spPr>
           <a:xfrm>
-            <a:off x="548640" y="1042416"/>
+            <a:off x="548640" y="932688"/>
             <a:ext cx="11064240" cy="365760"/>
           </a:xfrm>
           <a:prstGeom prst="rect">
@@ -18086,7 +18086,7 @@
         </p:nvSpPr>
         <p:spPr>
           <a:xfrm>
-            <a:off x="548640" y="813816"/>
+            <a:off x="548640" y="868680"/>
             <a:ext cx="960120" cy="41148"/>
           </a:xfrm>
           <a:prstGeom prst="rect">
@@ -19042,7 +19042,7 @@
         </p:nvSpPr>
         <p:spPr>
           <a:xfrm>
-            <a:off x="548640" y="457200"/>
+            <a:off x="548640" y="384048"/>
             <a:ext cx="11064240" cy="640080"/>
           </a:xfrm>
           <a:prstGeom prst="rect">
@@ -19083,7 +19083,7 @@
         </p:nvSpPr>
         <p:spPr>
           <a:xfrm>
-            <a:off x="548640" y="1042416"/>
+            <a:off x="548640" y="932688"/>
             <a:ext cx="11064240" cy="365760"/>
           </a:xfrm>
           <a:prstGeom prst="rect">
@@ -19131,7 +19131,7 @@
         </p:nvSpPr>
         <p:spPr>
           <a:xfrm>
-            <a:off x="548640" y="813816"/>
+            <a:off x="548640" y="868680"/>
             <a:ext cx="960120" cy="41148"/>
           </a:xfrm>
           <a:prstGeom prst="rect">
@@ -20840,7 +20840,7 @@
         </p:nvSpPr>
         <p:spPr>
           <a:xfrm>
-            <a:off x="548640" y="457200"/>
+            <a:off x="548640" y="384048"/>
             <a:ext cx="11064240" cy="640080"/>
           </a:xfrm>
           <a:prstGeom prst="rect">
@@ -20881,7 +20881,7 @@
         </p:nvSpPr>
         <p:spPr>
           <a:xfrm>
-            <a:off x="548640" y="1042416"/>
+            <a:off x="548640" y="932688"/>
             <a:ext cx="11064240" cy="365760"/>
           </a:xfrm>
           <a:prstGeom prst="rect">
@@ -20929,7 +20929,7 @@
         </p:nvSpPr>
         <p:spPr>
           <a:xfrm>
-            <a:off x="548640" y="813816"/>
+            <a:off x="548640" y="868680"/>
             <a:ext cx="960120" cy="41148"/>
           </a:xfrm>
           <a:prstGeom prst="rect">

</xml_diff>

<commit_message>
PPT: alargar los recuadros de codigo S5/S10/S13 para que el codigo no quede corto (retoques hechos a mano en pptx portados al script)
</commit_message>
<xml_diff>
--- a/presentacion/TimescaleDB-PPT-Javier.pptx
+++ b/presentacion/TimescaleDB-PPT-Javier.pptx
@@ -3871,7 +3871,7 @@
         <p:spPr>
           <a:xfrm>
             <a:off x="548640" y="2011680"/>
-            <a:ext cx="7680960" cy="1554480"/>
+            <a:ext cx="7680960" cy="1783080"/>
           </a:xfrm>
           <a:prstGeom prst="roundRect">
             <a:avLst>
@@ -3917,7 +3917,7 @@
         <p:spPr>
           <a:xfrm>
             <a:off x="777240" y="2148840"/>
-            <a:ext cx="7223760" cy="1280160"/>
+            <a:ext cx="7223760" cy="1508760"/>
           </a:xfrm>
           <a:prstGeom prst="rect">
             <a:avLst/>
@@ -7211,7 +7211,7 @@
         <p:spPr>
           <a:xfrm>
             <a:off x="548640" y="1965960"/>
-            <a:ext cx="7680960" cy="1143000"/>
+            <a:ext cx="7680960" cy="1362456"/>
           </a:xfrm>
           <a:prstGeom prst="roundRect">
             <a:avLst>
@@ -7257,7 +7257,7 @@
         <p:spPr>
           <a:xfrm>
             <a:off x="777240" y="2103120"/>
-            <a:ext cx="7223760" cy="868680"/>
+            <a:ext cx="7223760" cy="1088136"/>
           </a:xfrm>
           <a:prstGeom prst="rect">
             <a:avLst/>
@@ -17242,7 +17242,7 @@
         <p:spPr>
           <a:xfrm>
             <a:off x="548640" y="3794760"/>
-            <a:ext cx="7680960" cy="960120"/>
+            <a:ext cx="7680960" cy="1490472"/>
           </a:xfrm>
           <a:prstGeom prst="roundRect">
             <a:avLst>
@@ -17288,7 +17288,7 @@
         <p:spPr>
           <a:xfrm>
             <a:off x="777240" y="3931920"/>
-            <a:ext cx="7223760" cy="685800"/>
+            <a:ext cx="7223760" cy="1216151"/>
           </a:xfrm>
           <a:prstGeom prst="rect">
             <a:avLst/>

</xml_diff>

<commit_message>
PPT agenda: numerar de forma continua (01-12) en vez de repetir 01-06 en cada columna
</commit_message>
<xml_diff>
--- a/presentacion/TimescaleDB-PPT-Javier.pptx
+++ b/presentacion/TimescaleDB-PPT-Javier.pptx
@@ -15638,7 +15638,7 @@
                 </a:solidFill>
                 <a:latin typeface="Helvetica Neue"/>
               </a:rPr>
-              <a:t>01   Retención / autopurga — el historial se borra solo</a:t>
+              <a:t>07   Retención / autopurga — el historial se borra solo</a:t>
             </a:r>
           </a:p>
           <a:p>
@@ -15663,7 +15663,7 @@
                 </a:solidFill>
                 <a:latin typeface="Helvetica Neue"/>
               </a:rPr>
-              <a:t>02   time_bucket — downsampling 240 → 24</a:t>
+              <a:t>08   time_bucket — downsampling 240 → 24</a:t>
             </a:r>
           </a:p>
           <a:p>
@@ -15688,7 +15688,7 @@
                 </a:solidFill>
                 <a:latin typeface="Helvetica Neue"/>
               </a:rPr>
-              <a:t>03   Continuous aggregates — el resumen precalculado</a:t>
+              <a:t>09   Continuous aggregates — el resumen precalculado</a:t>
             </a:r>
           </a:p>
           <a:p>
@@ -15713,7 +15713,7 @@
                 </a:solidFill>
                 <a:latin typeface="Helvetica Neue"/>
               </a:rPr>
-              <a:t>04   Jobs personalizados — Timescale como cron</a:t>
+              <a:t>10   Jobs personalizados — Timescale como cron</a:t>
             </a:r>
           </a:p>
           <a:p>
@@ -15738,7 +15738,7 @@
                 </a:solidFill>
                 <a:latin typeface="Helvetica Neue"/>
               </a:rPr>
-              <a:t>05   Tuning de parámetros — Timescale + PostgreSQL</a:t>
+              <a:t>11   Tuning de parámetros — Timescale + PostgreSQL</a:t>
             </a:r>
           </a:p>
           <a:p>
@@ -15763,7 +15763,7 @@
                 </a:solidFill>
                 <a:latin typeface="Helvetica Neue"/>
               </a:rPr>
-              <a:t>06   El círculo de la telemetría — resumen</a:t>
+              <a:t>12   El círculo de la telemetría — resumen</a:t>
             </a:r>
           </a:p>
         </p:txBody>

</xml_diff>